<commit_message>
Add 4 new slides to Changes deck covering June 23 session
Slides 12–15 document this session's UI polish:
- Forecast chart rebuilt as smooth gradient area (Catmull-Rom curve)
- Card buttons: visual hierarchy (ghost View PIN + solid Freeze/Unfreeze)
- Biometric picker: segmented control pattern (grey track, lifted white card)
- VAT countdown overlay: calmer framing, grey cancel button, larger ring

Co-Authored-By: Claude Opus 4.8 <noreply@anthropic.com>
Claude-Session: https://claude.ai/code/session_012EFETGbhdxdnPCjpmQ9UDz
</commit_message>
<xml_diff>
--- a/Santander_June2026_Changes.pptx
+++ b/Santander_June2026_Changes.pptx
@@ -16,6 +16,10 @@
     <p:sldId id="264" r:id="rId15"/>
     <p:sldId id="265" r:id="rId16"/>
     <p:sldId id="266" r:id="rId17"/>
+    <p:sldId id="267" r:id="rId18"/>
+    <p:sldId id="268" r:id="rId19"/>
+    <p:sldId id="269" r:id="rId20"/>
+    <p:sldId id="270" r:id="rId21"/>
   </p:sldIdLst>
   <p:sldSz cx="12188952" cy="6858000" type="screen4x3"/>
   <p:notesSz cx="6858000" cy="9144000"/>
@@ -4784,6 +4788,3078 @@
                 </a:solidFill>
               </a:rPr>
               <a:t>All other files unchanged from previous session</a:t>
+            </a:r>
+          </a:p>
+        </p:txBody>
+      </p:sp>
+    </p:spTree>
+  </p:cSld>
+  <p:clrMapOvr>
+    <a:masterClrMapping/>
+  </p:clrMapOvr>
+</p:sld>
+</file>
+
+<file path=ppt/slides/slide12.xml><?xml version="1.0" encoding="utf-8"?>
+<p:sld xmlns:a="http://schemas.openxmlformats.org/drawingml/2006/main" xmlns:p="http://schemas.openxmlformats.org/presentationml/2006/main" xmlns:r="http://schemas.openxmlformats.org/officeDocument/2006/relationships">
+  <p:cSld>
+    <p:spTree>
+      <p:nvGrpSpPr>
+        <p:cNvPr id="1" name=""/>
+        <p:cNvGrpSpPr/>
+        <p:nvPr/>
+      </p:nvGrpSpPr>
+      <p:grpSpPr/>
+      <p:sp>
+        <p:nvSpPr>
+          <p:cNvPr id="2" name="Rectangle 1"/>
+          <p:cNvSpPr/>
+          <p:nvPr/>
+        </p:nvSpPr>
+        <p:spPr>
+          <a:xfrm>
+            <a:off x="0" y="0"/>
+            <a:ext cx="12188952" cy="73152"/>
+          </a:xfrm>
+          <a:prstGeom prst="rect">
+            <a:avLst/>
+          </a:prstGeom>
+          <a:solidFill>
+            <a:srgbClr val="C8102E"/>
+          </a:solidFill>
+          <a:ln>
+            <a:noFill/>
+          </a:ln>
+        </p:spPr>
+        <p:style>
+          <a:lnRef idx="1">
+            <a:schemeClr val="accent1"/>
+          </a:lnRef>
+          <a:fillRef idx="3">
+            <a:schemeClr val="accent1"/>
+          </a:fillRef>
+          <a:effectRef idx="2">
+            <a:schemeClr val="accent1"/>
+          </a:effectRef>
+          <a:fontRef idx="minor">
+            <a:schemeClr val="lt1"/>
+          </a:fontRef>
+        </p:style>
+        <p:txBody>
+          <a:bodyPr rtlCol="0" anchor="ctr"/>
+          <a:lstStyle/>
+          <a:p>
+            <a:pPr algn="ctr"/>
+          </a:p>
+        </p:txBody>
+      </p:sp>
+      <p:sp>
+        <p:nvSpPr>
+          <p:cNvPr id="3" name="Rectangle 2"/>
+          <p:cNvSpPr/>
+          <p:nvPr/>
+        </p:nvSpPr>
+        <p:spPr>
+          <a:xfrm>
+            <a:off x="0" y="73152"/>
+            <a:ext cx="12188952" cy="6784848"/>
+          </a:xfrm>
+          <a:prstGeom prst="rect">
+            <a:avLst/>
+          </a:prstGeom>
+          <a:solidFill>
+            <a:srgbClr val="FAF6EF"/>
+          </a:solidFill>
+          <a:ln>
+            <a:noFill/>
+          </a:ln>
+        </p:spPr>
+        <p:style>
+          <a:lnRef idx="1">
+            <a:schemeClr val="accent1"/>
+          </a:lnRef>
+          <a:fillRef idx="3">
+            <a:schemeClr val="accent1"/>
+          </a:fillRef>
+          <a:effectRef idx="2">
+            <a:schemeClr val="accent1"/>
+          </a:effectRef>
+          <a:fontRef idx="minor">
+            <a:schemeClr val="lt1"/>
+          </a:fontRef>
+        </p:style>
+        <p:txBody>
+          <a:bodyPr rtlCol="0" anchor="ctr"/>
+          <a:lstStyle/>
+          <a:p>
+            <a:pPr algn="ctr"/>
+          </a:p>
+        </p:txBody>
+      </p:sp>
+      <p:sp>
+        <p:nvSpPr>
+          <p:cNvPr id="4" name="TextBox 3"/>
+          <p:cNvSpPr txBox="1"/>
+          <p:nvPr/>
+        </p:nvSpPr>
+        <p:spPr>
+          <a:xfrm>
+            <a:off x="457200" y="91152"/>
+            <a:ext cx="4000000" cy="320000"/>
+          </a:xfrm>
+          <a:prstGeom prst="rect">
+            <a:avLst/>
+          </a:prstGeom>
+          <a:noFill/>
+        </p:spPr>
+        <p:txBody>
+          <a:bodyPr wrap="square" lIns="0" rIns="0" tIns="0" bIns="0">
+            <a:spAutoFit/>
+          </a:bodyPr>
+          <a:lstStyle/>
+          <a:p>
+            <a:pPr algn="l"/>
+            <a:r>
+              <a:rPr sz="900" b="1">
+                <a:solidFill>
+                  <a:srgbClr val="C8102E"/>
+                </a:solidFill>
+              </a:rPr>
+              <a:t>SESSION 2  —  23 June 2026</a:t>
+            </a:r>
+          </a:p>
+        </p:txBody>
+      </p:sp>
+      <p:sp>
+        <p:nvSpPr>
+          <p:cNvPr id="5" name="TextBox 4"/>
+          <p:cNvSpPr txBox="1"/>
+          <p:nvPr/>
+        </p:nvSpPr>
+        <p:spPr>
+          <a:xfrm>
+            <a:off x="10931752" y="91152"/>
+            <a:ext cx="760000" cy="320000"/>
+          </a:xfrm>
+          <a:prstGeom prst="rect">
+            <a:avLst/>
+          </a:prstGeom>
+          <a:noFill/>
+        </p:spPr>
+        <p:txBody>
+          <a:bodyPr wrap="square" lIns="0" rIns="0" tIns="0" bIns="0">
+            <a:spAutoFit/>
+          </a:bodyPr>
+          <a:lstStyle/>
+          <a:p>
+            <a:pPr algn="r"/>
+            <a:r>
+              <a:rPr sz="900" b="0">
+                <a:solidFill>
+                  <a:srgbClr val="78716C"/>
+                </a:solidFill>
+              </a:rPr>
+              <a:t>12 / 15</a:t>
+            </a:r>
+          </a:p>
+        </p:txBody>
+      </p:sp>
+      <p:sp>
+        <p:nvSpPr>
+          <p:cNvPr id="6" name="TextBox 5"/>
+          <p:cNvSpPr txBox="1"/>
+          <p:nvPr/>
+        </p:nvSpPr>
+        <p:spPr>
+          <a:xfrm>
+            <a:off x="457200" y="228600"/>
+            <a:ext cx="11091672" cy="640080"/>
+          </a:xfrm>
+          <a:prstGeom prst="rect">
+            <a:avLst/>
+          </a:prstGeom>
+          <a:noFill/>
+        </p:spPr>
+        <p:txBody>
+          <a:bodyPr wrap="square" lIns="0" rIns="0" tIns="0" bIns="0">
+            <a:spAutoFit/>
+          </a:bodyPr>
+          <a:lstStyle/>
+          <a:p>
+            <a:pPr algn="l"/>
+            <a:r>
+              <a:rPr sz="2600" b="1">
+                <a:solidFill>
+                  <a:srgbClr val="1A1A1A"/>
+                </a:solidFill>
+              </a:rPr>
+              <a:t>Forecast Chart — Smooth Gradient Area Rebuild</a:t>
+            </a:r>
+          </a:p>
+        </p:txBody>
+      </p:sp>
+      <p:sp>
+        <p:nvSpPr>
+          <p:cNvPr id="7" name="Rectangle 6"/>
+          <p:cNvSpPr/>
+          <p:nvPr/>
+        </p:nvSpPr>
+        <p:spPr>
+          <a:xfrm>
+            <a:off x="457200" y="868680"/>
+            <a:ext cx="11274552" cy="36576"/>
+          </a:xfrm>
+          <a:prstGeom prst="rect">
+            <a:avLst/>
+          </a:prstGeom>
+          <a:solidFill>
+            <a:srgbClr val="C8102E"/>
+          </a:solidFill>
+          <a:ln>
+            <a:noFill/>
+          </a:ln>
+        </p:spPr>
+        <p:style>
+          <a:lnRef idx="1">
+            <a:schemeClr val="accent1"/>
+          </a:lnRef>
+          <a:fillRef idx="3">
+            <a:schemeClr val="accent1"/>
+          </a:fillRef>
+          <a:effectRef idx="2">
+            <a:schemeClr val="accent1"/>
+          </a:effectRef>
+          <a:fontRef idx="minor">
+            <a:schemeClr val="lt1"/>
+          </a:fontRef>
+        </p:style>
+        <p:txBody>
+          <a:bodyPr rtlCol="0" anchor="ctr"/>
+          <a:lstStyle/>
+          <a:p>
+            <a:pPr algn="ctr"/>
+          </a:p>
+        </p:txBody>
+      </p:sp>
+      <p:sp>
+        <p:nvSpPr>
+          <p:cNvPr id="8" name="TextBox 7"/>
+          <p:cNvSpPr txBox="1"/>
+          <p:nvPr/>
+        </p:nvSpPr>
+        <p:spPr>
+          <a:xfrm>
+            <a:off x="457200" y="1097280"/>
+            <a:ext cx="11091672" cy="365760"/>
+          </a:xfrm>
+          <a:prstGeom prst="rect">
+            <a:avLst/>
+          </a:prstGeom>
+          <a:noFill/>
+        </p:spPr>
+        <p:txBody>
+          <a:bodyPr wrap="square" lIns="0" rIns="0" tIns="0" bIns="0">
+            <a:spAutoFit/>
+          </a:bodyPr>
+          <a:lstStyle/>
+          <a:p>
+            <a:pPr algn="l"/>
+            <a:r>
+              <a:rPr sz="1400" b="1">
+                <a:solidFill>
+                  <a:srgbClr val="C8102E"/>
+                </a:solidFill>
+              </a:rPr>
+              <a:t>Before</a:t>
+            </a:r>
+          </a:p>
+        </p:txBody>
+      </p:sp>
+      <p:sp>
+        <p:nvSpPr>
+          <p:cNvPr id="9" name="TextBox 8"/>
+          <p:cNvSpPr txBox="1"/>
+          <p:nvPr/>
+        </p:nvSpPr>
+        <p:spPr>
+          <a:xfrm>
+            <a:off x="640080" y="1463040"/>
+            <a:ext cx="10908792" cy="285750"/>
+          </a:xfrm>
+          <a:prstGeom prst="rect">
+            <a:avLst/>
+          </a:prstGeom>
+          <a:noFill/>
+        </p:spPr>
+        <p:txBody>
+          <a:bodyPr wrap="square" lIns="0" rIns="0" tIns="0" bIns="0">
+            <a:spAutoFit/>
+          </a:bodyPr>
+          <a:lstStyle/>
+          <a:p>
+            <a:pPr algn="l"/>
+            <a:r>
+              <a:rPr sz="1200" b="0">
+                <a:solidFill>
+                  <a:srgbClr val="1A1A1A"/>
+                </a:solidFill>
+              </a:rPr>
+              <a:t>▪  Flat coloured bars with no visual hierarchy — movement looked identical week-to-week</a:t>
+            </a:r>
+          </a:p>
+        </p:txBody>
+      </p:sp>
+      <p:sp>
+        <p:nvSpPr>
+          <p:cNvPr id="10" name="TextBox 9"/>
+          <p:cNvSpPr txBox="1"/>
+          <p:nvPr/>
+        </p:nvSpPr>
+        <p:spPr>
+          <a:xfrm>
+            <a:off x="640080" y="1748790"/>
+            <a:ext cx="10908792" cy="285750"/>
+          </a:xfrm>
+          <a:prstGeom prst="rect">
+            <a:avLst/>
+          </a:prstGeom>
+          <a:noFill/>
+        </p:spPr>
+        <p:txBody>
+          <a:bodyPr wrap="square" lIns="0" rIns="0" tIns="0" bIns="0">
+            <a:spAutoFit/>
+          </a:bodyPr>
+          <a:lstStyle/>
+          <a:p>
+            <a:pPr algn="l"/>
+            <a:r>
+              <a:rPr sz="1200" b="0">
+                <a:solidFill>
+                  <a:srgbClr val="1A1A1A"/>
+                </a:solidFill>
+              </a:rPr>
+              <a:t>▪  Chart axis started at zero, compressing weekly swings to near-invisible deltas</a:t>
+            </a:r>
+          </a:p>
+        </p:txBody>
+      </p:sp>
+      <p:sp>
+        <p:nvSpPr>
+          <p:cNvPr id="11" name="TextBox 10"/>
+          <p:cNvSpPr txBox="1"/>
+          <p:nvPr/>
+        </p:nvSpPr>
+        <p:spPr>
+          <a:xfrm>
+            <a:off x="640080" y="2034540"/>
+            <a:ext cx="10908792" cy="285750"/>
+          </a:xfrm>
+          <a:prstGeom prst="rect">
+            <a:avLst/>
+          </a:prstGeom>
+          <a:noFill/>
+        </p:spPr>
+        <p:txBody>
+          <a:bodyPr wrap="square" lIns="0" rIns="0" tIns="0" bIns="0">
+            <a:spAutoFit/>
+          </a:bodyPr>
+          <a:lstStyle/>
+          <a:p>
+            <a:pPr algn="l"/>
+            <a:r>
+              <a:rPr sz="1200" b="0">
+                <a:solidFill>
+                  <a:srgbClr val="1A1A1A"/>
+                </a:solidFill>
+              </a:rPr>
+              <a:t>▪  No event markers; no distinction between inflow weeks and outflow weeks</a:t>
+            </a:r>
+          </a:p>
+        </p:txBody>
+      </p:sp>
+      <p:sp>
+        <p:nvSpPr>
+          <p:cNvPr id="12" name="TextBox 11"/>
+          <p:cNvSpPr txBox="1"/>
+          <p:nvPr/>
+        </p:nvSpPr>
+        <p:spPr>
+          <a:xfrm>
+            <a:off x="640080" y="2320290"/>
+            <a:ext cx="10908792" cy="285750"/>
+          </a:xfrm>
+          <a:prstGeom prst="rect">
+            <a:avLst/>
+          </a:prstGeom>
+          <a:noFill/>
+        </p:spPr>
+        <p:txBody>
+          <a:bodyPr wrap="square" lIns="0" rIns="0" tIns="0" bIns="0">
+            <a:spAutoFit/>
+          </a:bodyPr>
+          <a:lstStyle/>
+          <a:p>
+            <a:pPr algn="l"/>
+            <a:r>
+              <a:rPr sz="1200" b="0">
+                <a:solidFill>
+                  <a:srgbClr val="1A1A1A"/>
+                </a:solidFill>
+              </a:rPr>
+              <a:t>▪  Amber floor warning (£80k) never triggered because the scale hid dips</a:t>
+            </a:r>
+          </a:p>
+        </p:txBody>
+      </p:sp>
+      <p:sp>
+        <p:nvSpPr>
+          <p:cNvPr id="13" name="TextBox 12"/>
+          <p:cNvSpPr txBox="1"/>
+          <p:nvPr/>
+        </p:nvSpPr>
+        <p:spPr>
+          <a:xfrm>
+            <a:off x="457200" y="2679192"/>
+            <a:ext cx="11091672" cy="365760"/>
+          </a:xfrm>
+          <a:prstGeom prst="rect">
+            <a:avLst/>
+          </a:prstGeom>
+          <a:noFill/>
+        </p:spPr>
+        <p:txBody>
+          <a:bodyPr wrap="square" lIns="0" rIns="0" tIns="0" bIns="0">
+            <a:spAutoFit/>
+          </a:bodyPr>
+          <a:lstStyle/>
+          <a:p>
+            <a:pPr algn="l"/>
+            <a:r>
+              <a:rPr sz="1400" b="1">
+                <a:solidFill>
+                  <a:srgbClr val="C8102E"/>
+                </a:solidFill>
+              </a:rPr>
+              <a:t>After</a:t>
+            </a:r>
+          </a:p>
+        </p:txBody>
+      </p:sp>
+      <p:sp>
+        <p:nvSpPr>
+          <p:cNvPr id="14" name="TextBox 13"/>
+          <p:cNvSpPr txBox="1"/>
+          <p:nvPr/>
+        </p:nvSpPr>
+        <p:spPr>
+          <a:xfrm>
+            <a:off x="640080" y="3044952"/>
+            <a:ext cx="10908792" cy="285750"/>
+          </a:xfrm>
+          <a:prstGeom prst="rect">
+            <a:avLst/>
+          </a:prstGeom>
+          <a:noFill/>
+        </p:spPr>
+        <p:txBody>
+          <a:bodyPr wrap="square" lIns="0" rIns="0" tIns="0" bIns="0">
+            <a:spAutoFit/>
+          </a:bodyPr>
+          <a:lstStyle/>
+          <a:p>
+            <a:pPr algn="l"/>
+            <a:r>
+              <a:rPr sz="1200" b="0">
+                <a:solidFill>
+                  <a:srgbClr val="1A1A1A"/>
+                </a:solidFill>
+              </a:rPr>
+              <a:t>▪  Smooth area chart using Catmull-Rom → cubic Bézier conversion for a natural curve</a:t>
+            </a:r>
+          </a:p>
+        </p:txBody>
+      </p:sp>
+      <p:sp>
+        <p:nvSpPr>
+          <p:cNvPr id="15" name="TextBox 14"/>
+          <p:cNvSpPr txBox="1"/>
+          <p:nvPr/>
+        </p:nvSpPr>
+        <p:spPr>
+          <a:xfrm>
+            <a:off x="640080" y="3330702"/>
+            <a:ext cx="10908792" cy="285750"/>
+          </a:xfrm>
+          <a:prstGeom prst="rect">
+            <a:avLst/>
+          </a:prstGeom>
+          <a:noFill/>
+        </p:spPr>
+        <p:txBody>
+          <a:bodyPr wrap="square" lIns="0" rIns="0" tIns="0" bIns="0">
+            <a:spAutoFit/>
+          </a:bodyPr>
+          <a:lstStyle/>
+          <a:p>
+            <a:pPr algn="l"/>
+            <a:r>
+              <a:rPr sz="1200" b="0">
+                <a:solidFill>
+                  <a:srgbClr val="1A1A1A"/>
+                </a:solidFill>
+              </a:rPr>
+              <a:t>▪  Y-axis zoomed to actual [min, max] balance band (+35% padding) — weekly movement is now legible</a:t>
+            </a:r>
+          </a:p>
+        </p:txBody>
+      </p:sp>
+      <p:sp>
+        <p:nvSpPr>
+          <p:cNvPr id="16" name="TextBox 15"/>
+          <p:cNvSpPr txBox="1"/>
+          <p:nvPr/>
+        </p:nvSpPr>
+        <p:spPr>
+          <a:xfrm>
+            <a:off x="640080" y="3616452"/>
+            <a:ext cx="10908792" cy="285750"/>
+          </a:xfrm>
+          <a:prstGeom prst="rect">
+            <a:avLst/>
+          </a:prstGeom>
+          <a:noFill/>
+        </p:spPr>
+        <p:txBody>
+          <a:bodyPr wrap="square" lIns="0" rIns="0" tIns="0" bIns="0">
+            <a:spAutoFit/>
+          </a:bodyPr>
+          <a:lstStyle/>
+          <a:p>
+            <a:pPr algn="l"/>
+            <a:r>
+              <a:rPr sz="1200" b="0">
+                <a:solidFill>
+                  <a:srgbClr val="1A1A1A"/>
+                </a:solidFill>
+              </a:rPr>
+              <a:t>▪  Event markers: red dot = largest outflow, rose dot = inflow, amber ring = lowest week</a:t>
+            </a:r>
+          </a:p>
+        </p:txBody>
+      </p:sp>
+      <p:sp>
+        <p:nvSpPr>
+          <p:cNvPr id="17" name="TextBox 16"/>
+          <p:cNvSpPr txBox="1"/>
+          <p:nvPr/>
+        </p:nvSpPr>
+        <p:spPr>
+          <a:xfrm>
+            <a:off x="640080" y="3902202"/>
+            <a:ext cx="10908792" cy="285750"/>
+          </a:xfrm>
+          <a:prstGeom prst="rect">
+            <a:avLst/>
+          </a:prstGeom>
+          <a:noFill/>
+        </p:spPr>
+        <p:txBody>
+          <a:bodyPr wrap="square" lIns="0" rIns="0" tIns="0" bIns="0">
+            <a:spAutoFit/>
+          </a:bodyPr>
+          <a:lstStyle/>
+          <a:p>
+            <a:pPr algn="l"/>
+            <a:r>
+              <a:rPr sz="1200" b="0">
+                <a:solidFill>
+                  <a:srgbClr val="1A1A1A"/>
+                </a:solidFill>
+              </a:rPr>
+              <a:t>▪  Event text block names the dominant scheduled outflow (e.g. 'VAT direct debit £41,614')</a:t>
+            </a:r>
+          </a:p>
+        </p:txBody>
+      </p:sp>
+      <p:sp>
+        <p:nvSpPr>
+          <p:cNvPr id="18" name="TextBox 17"/>
+          <p:cNvSpPr txBox="1"/>
+          <p:nvPr/>
+        </p:nvSpPr>
+        <p:spPr>
+          <a:xfrm>
+            <a:off x="640080" y="4187952"/>
+            <a:ext cx="10908792" cy="285750"/>
+          </a:xfrm>
+          <a:prstGeom prst="rect">
+            <a:avLst/>
+          </a:prstGeom>
+          <a:noFill/>
+        </p:spPr>
+        <p:txBody>
+          <a:bodyPr wrap="square" lIns="0" rIns="0" tIns="0" bIns="0">
+            <a:spAutoFit/>
+          </a:bodyPr>
+          <a:lstStyle/>
+          <a:p>
+            <a:pPr algn="l"/>
+            <a:r>
+              <a:rPr sz="1200" b="0">
+                <a:solidFill>
+                  <a:srgbClr val="1A1A1A"/>
+                </a:solidFill>
+              </a:rPr>
+              <a:t>▪  Amber warning fires when balance dips below the £80k floor</a:t>
+            </a:r>
+          </a:p>
+        </p:txBody>
+      </p:sp>
+      <p:sp>
+        <p:nvSpPr>
+          <p:cNvPr id="19" name="TextBox 18"/>
+          <p:cNvSpPr txBox="1"/>
+          <p:nvPr/>
+        </p:nvSpPr>
+        <p:spPr>
+          <a:xfrm>
+            <a:off x="457200" y="4546854"/>
+            <a:ext cx="11091672" cy="365760"/>
+          </a:xfrm>
+          <a:prstGeom prst="rect">
+            <a:avLst/>
+          </a:prstGeom>
+          <a:noFill/>
+        </p:spPr>
+        <p:txBody>
+          <a:bodyPr wrap="square" lIns="0" rIns="0" tIns="0" bIns="0">
+            <a:spAutoFit/>
+          </a:bodyPr>
+          <a:lstStyle/>
+          <a:p>
+            <a:pPr algn="l"/>
+            <a:r>
+              <a:rPr sz="1400" b="1">
+                <a:solidFill>
+                  <a:srgbClr val="C8102E"/>
+                </a:solidFill>
+              </a:rPr>
+              <a:t>Why it matters</a:t>
+            </a:r>
+          </a:p>
+        </p:txBody>
+      </p:sp>
+      <p:sp>
+        <p:nvSpPr>
+          <p:cNvPr id="20" name="TextBox 19"/>
+          <p:cNvSpPr txBox="1"/>
+          <p:nvPr/>
+        </p:nvSpPr>
+        <p:spPr>
+          <a:xfrm>
+            <a:off x="640080" y="4912614"/>
+            <a:ext cx="10908792" cy="285750"/>
+          </a:xfrm>
+          <a:prstGeom prst="rect">
+            <a:avLst/>
+          </a:prstGeom>
+          <a:noFill/>
+        </p:spPr>
+        <p:txBody>
+          <a:bodyPr wrap="square" lIns="0" rIns="0" tIns="0" bIns="0">
+            <a:spAutoFit/>
+          </a:bodyPr>
+          <a:lstStyle/>
+          <a:p>
+            <a:pPr algn="l"/>
+            <a:r>
+              <a:rPr sz="1200" b="0">
+                <a:solidFill>
+                  <a:srgbClr val="1A1A1A"/>
+                </a:solidFill>
+              </a:rPr>
+              <a:t>▪  A cash-flow chart that looks flat communicates nothing. The rebuild makes variance immediately visible</a:t>
+            </a:r>
+          </a:p>
+        </p:txBody>
+      </p:sp>
+      <p:sp>
+        <p:nvSpPr>
+          <p:cNvPr id="21" name="TextBox 20"/>
+          <p:cNvSpPr txBox="1"/>
+          <p:nvPr/>
+        </p:nvSpPr>
+        <p:spPr>
+          <a:xfrm>
+            <a:off x="640080" y="5198364"/>
+            <a:ext cx="10908792" cy="285750"/>
+          </a:xfrm>
+          <a:prstGeom prst="rect">
+            <a:avLst/>
+          </a:prstGeom>
+          <a:noFill/>
+        </p:spPr>
+        <p:txBody>
+          <a:bodyPr wrap="square" lIns="0" rIns="0" tIns="0" bIns="0">
+            <a:spAutoFit/>
+          </a:bodyPr>
+          <a:lstStyle/>
+          <a:p>
+            <a:pPr algn="l"/>
+            <a:r>
+              <a:rPr sz="1200" b="0">
+                <a:solidFill>
+                  <a:srgbClr val="1A1A1A"/>
+                </a:solidFill>
+              </a:rPr>
+              <a:t>▪  and gives the SME owner one named event to act on — the core job of a forecast widget.</a:t>
+            </a:r>
+          </a:p>
+        </p:txBody>
+      </p:sp>
+      <p:sp>
+        <p:nvSpPr>
+          <p:cNvPr id="22" name="Rectangle 21"/>
+          <p:cNvSpPr/>
+          <p:nvPr/>
+        </p:nvSpPr>
+        <p:spPr>
+          <a:xfrm>
+            <a:off x="457200" y="6217920"/>
+            <a:ext cx="11274552" cy="457200"/>
+          </a:xfrm>
+          <a:prstGeom prst="rect">
+            <a:avLst/>
+          </a:prstGeom>
+          <a:solidFill>
+            <a:srgbClr val="F5F0E8"/>
+          </a:solidFill>
+          <a:ln>
+            <a:noFill/>
+          </a:ln>
+        </p:spPr>
+        <p:style>
+          <a:lnRef idx="1">
+            <a:schemeClr val="accent1"/>
+          </a:lnRef>
+          <a:fillRef idx="3">
+            <a:schemeClr val="accent1"/>
+          </a:fillRef>
+          <a:effectRef idx="2">
+            <a:schemeClr val="accent1"/>
+          </a:effectRef>
+          <a:fontRef idx="minor">
+            <a:schemeClr val="lt1"/>
+          </a:fontRef>
+        </p:style>
+        <p:txBody>
+          <a:bodyPr rtlCol="0" anchor="ctr"/>
+          <a:lstStyle/>
+          <a:p>
+            <a:pPr algn="ctr"/>
+          </a:p>
+        </p:txBody>
+      </p:sp>
+      <p:sp>
+        <p:nvSpPr>
+          <p:cNvPr id="23" name="TextBox 22"/>
+          <p:cNvSpPr txBox="1"/>
+          <p:nvPr/>
+        </p:nvSpPr>
+        <p:spPr>
+          <a:xfrm>
+            <a:off x="640080" y="6263640"/>
+            <a:ext cx="11091672" cy="365760"/>
+          </a:xfrm>
+          <a:prstGeom prst="rect">
+            <a:avLst/>
+          </a:prstGeom>
+          <a:noFill/>
+        </p:spPr>
+        <p:txBody>
+          <a:bodyPr wrap="square" lIns="0" rIns="0" tIns="0" bIns="0">
+            <a:spAutoFit/>
+          </a:bodyPr>
+          <a:lstStyle/>
+          <a:p>
+            <a:pPr algn="l"/>
+            <a:r>
+              <a:rPr sz="1000" b="0">
+                <a:solidFill>
+                  <a:srgbClr val="78716C"/>
+                </a:solidFill>
+              </a:rPr>
+              <a:t>Session 2 · 23 Jun 2026  ·  forecast useMemo ~line 609, render block ~line 3207</a:t>
+            </a:r>
+          </a:p>
+        </p:txBody>
+      </p:sp>
+    </p:spTree>
+  </p:cSld>
+  <p:clrMapOvr>
+    <a:masterClrMapping/>
+  </p:clrMapOvr>
+</p:sld>
+</file>
+
+<file path=ppt/slides/slide13.xml><?xml version="1.0" encoding="utf-8"?>
+<p:sld xmlns:a="http://schemas.openxmlformats.org/drawingml/2006/main" xmlns:p="http://schemas.openxmlformats.org/presentationml/2006/main" xmlns:r="http://schemas.openxmlformats.org/officeDocument/2006/relationships">
+  <p:cSld>
+    <p:spTree>
+      <p:nvGrpSpPr>
+        <p:cNvPr id="1" name=""/>
+        <p:cNvGrpSpPr/>
+        <p:nvPr/>
+      </p:nvGrpSpPr>
+      <p:grpSpPr/>
+      <p:sp>
+        <p:nvSpPr>
+          <p:cNvPr id="2" name="Rectangle 1"/>
+          <p:cNvSpPr/>
+          <p:nvPr/>
+        </p:nvSpPr>
+        <p:spPr>
+          <a:xfrm>
+            <a:off x="0" y="0"/>
+            <a:ext cx="12188952" cy="73152"/>
+          </a:xfrm>
+          <a:prstGeom prst="rect">
+            <a:avLst/>
+          </a:prstGeom>
+          <a:solidFill>
+            <a:srgbClr val="C8102E"/>
+          </a:solidFill>
+          <a:ln>
+            <a:noFill/>
+          </a:ln>
+        </p:spPr>
+        <p:style>
+          <a:lnRef idx="1">
+            <a:schemeClr val="accent1"/>
+          </a:lnRef>
+          <a:fillRef idx="3">
+            <a:schemeClr val="accent1"/>
+          </a:fillRef>
+          <a:effectRef idx="2">
+            <a:schemeClr val="accent1"/>
+          </a:effectRef>
+          <a:fontRef idx="minor">
+            <a:schemeClr val="lt1"/>
+          </a:fontRef>
+        </p:style>
+        <p:txBody>
+          <a:bodyPr rtlCol="0" anchor="ctr"/>
+          <a:lstStyle/>
+          <a:p>
+            <a:pPr algn="ctr"/>
+          </a:p>
+        </p:txBody>
+      </p:sp>
+      <p:sp>
+        <p:nvSpPr>
+          <p:cNvPr id="3" name="Rectangle 2"/>
+          <p:cNvSpPr/>
+          <p:nvPr/>
+        </p:nvSpPr>
+        <p:spPr>
+          <a:xfrm>
+            <a:off x="0" y="73152"/>
+            <a:ext cx="12188952" cy="6784848"/>
+          </a:xfrm>
+          <a:prstGeom prst="rect">
+            <a:avLst/>
+          </a:prstGeom>
+          <a:solidFill>
+            <a:srgbClr val="FAF6EF"/>
+          </a:solidFill>
+          <a:ln>
+            <a:noFill/>
+          </a:ln>
+        </p:spPr>
+        <p:style>
+          <a:lnRef idx="1">
+            <a:schemeClr val="accent1"/>
+          </a:lnRef>
+          <a:fillRef idx="3">
+            <a:schemeClr val="accent1"/>
+          </a:fillRef>
+          <a:effectRef idx="2">
+            <a:schemeClr val="accent1"/>
+          </a:effectRef>
+          <a:fontRef idx="minor">
+            <a:schemeClr val="lt1"/>
+          </a:fontRef>
+        </p:style>
+        <p:txBody>
+          <a:bodyPr rtlCol="0" anchor="ctr"/>
+          <a:lstStyle/>
+          <a:p>
+            <a:pPr algn="ctr"/>
+          </a:p>
+        </p:txBody>
+      </p:sp>
+      <p:sp>
+        <p:nvSpPr>
+          <p:cNvPr id="4" name="TextBox 3"/>
+          <p:cNvSpPr txBox="1"/>
+          <p:nvPr/>
+        </p:nvSpPr>
+        <p:spPr>
+          <a:xfrm>
+            <a:off x="457200" y="91152"/>
+            <a:ext cx="4000000" cy="320000"/>
+          </a:xfrm>
+          <a:prstGeom prst="rect">
+            <a:avLst/>
+          </a:prstGeom>
+          <a:noFill/>
+        </p:spPr>
+        <p:txBody>
+          <a:bodyPr wrap="square" lIns="0" rIns="0" tIns="0" bIns="0">
+            <a:spAutoFit/>
+          </a:bodyPr>
+          <a:lstStyle/>
+          <a:p>
+            <a:pPr algn="l"/>
+            <a:r>
+              <a:rPr sz="900" b="1">
+                <a:solidFill>
+                  <a:srgbClr val="C8102E"/>
+                </a:solidFill>
+              </a:rPr>
+              <a:t>SESSION 2  —  23 June 2026</a:t>
+            </a:r>
+          </a:p>
+        </p:txBody>
+      </p:sp>
+      <p:sp>
+        <p:nvSpPr>
+          <p:cNvPr id="5" name="TextBox 4"/>
+          <p:cNvSpPr txBox="1"/>
+          <p:nvPr/>
+        </p:nvSpPr>
+        <p:spPr>
+          <a:xfrm>
+            <a:off x="10931752" y="91152"/>
+            <a:ext cx="760000" cy="320000"/>
+          </a:xfrm>
+          <a:prstGeom prst="rect">
+            <a:avLst/>
+          </a:prstGeom>
+          <a:noFill/>
+        </p:spPr>
+        <p:txBody>
+          <a:bodyPr wrap="square" lIns="0" rIns="0" tIns="0" bIns="0">
+            <a:spAutoFit/>
+          </a:bodyPr>
+          <a:lstStyle/>
+          <a:p>
+            <a:pPr algn="r"/>
+            <a:r>
+              <a:rPr sz="900" b="0">
+                <a:solidFill>
+                  <a:srgbClr val="78716C"/>
+                </a:solidFill>
+              </a:rPr>
+              <a:t>13 / 15</a:t>
+            </a:r>
+          </a:p>
+        </p:txBody>
+      </p:sp>
+      <p:sp>
+        <p:nvSpPr>
+          <p:cNvPr id="6" name="TextBox 5"/>
+          <p:cNvSpPr txBox="1"/>
+          <p:nvPr/>
+        </p:nvSpPr>
+        <p:spPr>
+          <a:xfrm>
+            <a:off x="457200" y="228600"/>
+            <a:ext cx="11091672" cy="640080"/>
+          </a:xfrm>
+          <a:prstGeom prst="rect">
+            <a:avLst/>
+          </a:prstGeom>
+          <a:noFill/>
+        </p:spPr>
+        <p:txBody>
+          <a:bodyPr wrap="square" lIns="0" rIns="0" tIns="0" bIns="0">
+            <a:spAutoFit/>
+          </a:bodyPr>
+          <a:lstStyle/>
+          <a:p>
+            <a:pPr algn="l"/>
+            <a:r>
+              <a:rPr sz="2600" b="1">
+                <a:solidFill>
+                  <a:srgbClr val="1A1A1A"/>
+                </a:solidFill>
+              </a:rPr>
+              <a:t>Card Buttons — Visual Hierarchy Polish</a:t>
+            </a:r>
+          </a:p>
+        </p:txBody>
+      </p:sp>
+      <p:sp>
+        <p:nvSpPr>
+          <p:cNvPr id="7" name="Rectangle 6"/>
+          <p:cNvSpPr/>
+          <p:nvPr/>
+        </p:nvSpPr>
+        <p:spPr>
+          <a:xfrm>
+            <a:off x="457200" y="868680"/>
+            <a:ext cx="11274552" cy="36576"/>
+          </a:xfrm>
+          <a:prstGeom prst="rect">
+            <a:avLst/>
+          </a:prstGeom>
+          <a:solidFill>
+            <a:srgbClr val="C8102E"/>
+          </a:solidFill>
+          <a:ln>
+            <a:noFill/>
+          </a:ln>
+        </p:spPr>
+        <p:style>
+          <a:lnRef idx="1">
+            <a:schemeClr val="accent1"/>
+          </a:lnRef>
+          <a:fillRef idx="3">
+            <a:schemeClr val="accent1"/>
+          </a:fillRef>
+          <a:effectRef idx="2">
+            <a:schemeClr val="accent1"/>
+          </a:effectRef>
+          <a:fontRef idx="minor">
+            <a:schemeClr val="lt1"/>
+          </a:fontRef>
+        </p:style>
+        <p:txBody>
+          <a:bodyPr rtlCol="0" anchor="ctr"/>
+          <a:lstStyle/>
+          <a:p>
+            <a:pPr algn="ctr"/>
+          </a:p>
+        </p:txBody>
+      </p:sp>
+      <p:sp>
+        <p:nvSpPr>
+          <p:cNvPr id="8" name="TextBox 7"/>
+          <p:cNvSpPr txBox="1"/>
+          <p:nvPr/>
+        </p:nvSpPr>
+        <p:spPr>
+          <a:xfrm>
+            <a:off x="457200" y="1097280"/>
+            <a:ext cx="11091672" cy="365760"/>
+          </a:xfrm>
+          <a:prstGeom prst="rect">
+            <a:avLst/>
+          </a:prstGeom>
+          <a:noFill/>
+        </p:spPr>
+        <p:txBody>
+          <a:bodyPr wrap="square" lIns="0" rIns="0" tIns="0" bIns="0">
+            <a:spAutoFit/>
+          </a:bodyPr>
+          <a:lstStyle/>
+          <a:p>
+            <a:pPr algn="l"/>
+            <a:r>
+              <a:rPr sz="1400" b="1">
+                <a:solidFill>
+                  <a:srgbClr val="C8102E"/>
+                </a:solidFill>
+              </a:rPr>
+              <a:t>Before</a:t>
+            </a:r>
+          </a:p>
+        </p:txBody>
+      </p:sp>
+      <p:sp>
+        <p:nvSpPr>
+          <p:cNvPr id="9" name="TextBox 8"/>
+          <p:cNvSpPr txBox="1"/>
+          <p:nvPr/>
+        </p:nvSpPr>
+        <p:spPr>
+          <a:xfrm>
+            <a:off x="640080" y="1463040"/>
+            <a:ext cx="10908792" cy="285750"/>
+          </a:xfrm>
+          <a:prstGeom prst="rect">
+            <a:avLst/>
+          </a:prstGeom>
+          <a:noFill/>
+        </p:spPr>
+        <p:txBody>
+          <a:bodyPr wrap="square" lIns="0" rIns="0" tIns="0" bIns="0">
+            <a:spAutoFit/>
+          </a:bodyPr>
+          <a:lstStyle/>
+          <a:p>
+            <a:pPr algn="l"/>
+            <a:r>
+              <a:rPr sz="1200" b="0">
+                <a:solidFill>
+                  <a:srgbClr val="1A1A1A"/>
+                </a:solidFill>
+              </a:rPr>
+              <a:t>▪  Two ghost buttons ("View PIN" and "Freeze") with identical weight and styling</a:t>
+            </a:r>
+          </a:p>
+        </p:txBody>
+      </p:sp>
+      <p:sp>
+        <p:nvSpPr>
+          <p:cNvPr id="10" name="TextBox 9"/>
+          <p:cNvSpPr txBox="1"/>
+          <p:nvPr/>
+        </p:nvSpPr>
+        <p:spPr>
+          <a:xfrm>
+            <a:off x="640080" y="1748790"/>
+            <a:ext cx="10908792" cy="285750"/>
+          </a:xfrm>
+          <a:prstGeom prst="rect">
+            <a:avLst/>
+          </a:prstGeom>
+          <a:noFill/>
+        </p:spPr>
+        <p:txBody>
+          <a:bodyPr wrap="square" lIns="0" rIns="0" tIns="0" bIns="0">
+            <a:spAutoFit/>
+          </a:bodyPr>
+          <a:lstStyle/>
+          <a:p>
+            <a:pPr algn="l"/>
+            <a:r>
+              <a:rPr sz="1200" b="0">
+                <a:solidFill>
+                  <a:srgbClr val="1A1A1A"/>
+                </a:solidFill>
+              </a:rPr>
+              <a:t>▪  No visual signal to distinguish a read-only action from a destructive one</a:t>
+            </a:r>
+          </a:p>
+        </p:txBody>
+      </p:sp>
+      <p:sp>
+        <p:nvSpPr>
+          <p:cNvPr id="11" name="TextBox 10"/>
+          <p:cNvSpPr txBox="1"/>
+          <p:nvPr/>
+        </p:nvSpPr>
+        <p:spPr>
+          <a:xfrm>
+            <a:off x="640080" y="2034540"/>
+            <a:ext cx="10908792" cy="285750"/>
+          </a:xfrm>
+          <a:prstGeom prst="rect">
+            <a:avLst/>
+          </a:prstGeom>
+          <a:noFill/>
+        </p:spPr>
+        <p:txBody>
+          <a:bodyPr wrap="square" lIns="0" rIns="0" tIns="0" bIns="0">
+            <a:spAutoFit/>
+          </a:bodyPr>
+          <a:lstStyle/>
+          <a:p>
+            <a:pPr algn="l"/>
+            <a:r>
+              <a:rPr sz="1200" b="0">
+                <a:solidFill>
+                  <a:srgbClr val="1A1A1A"/>
+                </a:solidFill>
+              </a:rPr>
+              <a:t>▪  "Unfreeze" used the same ghost style as the initial Freeze button</a:t>
+            </a:r>
+          </a:p>
+        </p:txBody>
+      </p:sp>
+      <p:sp>
+        <p:nvSpPr>
+          <p:cNvPr id="12" name="TextBox 11"/>
+          <p:cNvSpPr txBox="1"/>
+          <p:nvPr/>
+        </p:nvSpPr>
+        <p:spPr>
+          <a:xfrm>
+            <a:off x="457200" y="2393442"/>
+            <a:ext cx="11091672" cy="365760"/>
+          </a:xfrm>
+          <a:prstGeom prst="rect">
+            <a:avLst/>
+          </a:prstGeom>
+          <a:noFill/>
+        </p:spPr>
+        <p:txBody>
+          <a:bodyPr wrap="square" lIns="0" rIns="0" tIns="0" bIns="0">
+            <a:spAutoFit/>
+          </a:bodyPr>
+          <a:lstStyle/>
+          <a:p>
+            <a:pPr algn="l"/>
+            <a:r>
+              <a:rPr sz="1400" b="1">
+                <a:solidFill>
+                  <a:srgbClr val="C8102E"/>
+                </a:solidFill>
+              </a:rPr>
+              <a:t>After</a:t>
+            </a:r>
+          </a:p>
+        </p:txBody>
+      </p:sp>
+      <p:sp>
+        <p:nvSpPr>
+          <p:cNvPr id="13" name="TextBox 12"/>
+          <p:cNvSpPr txBox="1"/>
+          <p:nvPr/>
+        </p:nvSpPr>
+        <p:spPr>
+          <a:xfrm>
+            <a:off x="640080" y="2759202"/>
+            <a:ext cx="10908792" cy="285750"/>
+          </a:xfrm>
+          <a:prstGeom prst="rect">
+            <a:avLst/>
+          </a:prstGeom>
+          <a:noFill/>
+        </p:spPr>
+        <p:txBody>
+          <a:bodyPr wrap="square" lIns="0" rIns="0" tIns="0" bIns="0">
+            <a:spAutoFit/>
+          </a:bodyPr>
+          <a:lstStyle/>
+          <a:p>
+            <a:pPr algn="l"/>
+            <a:r>
+              <a:rPr sz="1200" b="0">
+                <a:solidFill>
+                  <a:srgbClr val="1A1A1A"/>
+                </a:solidFill>
+              </a:rPr>
+              <a:t>▪  "View PIN" — visible ghost: stone-50 background, stone-300 border, stone-800 text</a:t>
+            </a:r>
+          </a:p>
+        </p:txBody>
+      </p:sp>
+      <p:sp>
+        <p:nvSpPr>
+          <p:cNvPr id="14" name="TextBox 13"/>
+          <p:cNvSpPr txBox="1"/>
+          <p:nvPr/>
+        </p:nvSpPr>
+        <p:spPr>
+          <a:xfrm>
+            <a:off x="640080" y="3044952"/>
+            <a:ext cx="10908792" cy="285750"/>
+          </a:xfrm>
+          <a:prstGeom prst="rect">
+            <a:avLst/>
+          </a:prstGeom>
+          <a:noFill/>
+        </p:spPr>
+        <p:txBody>
+          <a:bodyPr wrap="square" lIns="0" rIns="0" tIns="0" bIns="0">
+            <a:spAutoFit/>
+          </a:bodyPr>
+          <a:lstStyle/>
+          <a:p>
+            <a:pPr algn="l"/>
+            <a:r>
+              <a:rPr sz="1200" b="0">
+                <a:solidFill>
+                  <a:srgbClr val="1A1A1A"/>
+                </a:solidFill>
+              </a:rPr>
+              <a:t>▪  "Freeze" — solid stone-900 fill (filled black), communicating a serious / committed action</a:t>
+            </a:r>
+          </a:p>
+        </p:txBody>
+      </p:sp>
+      <p:sp>
+        <p:nvSpPr>
+          <p:cNvPr id="15" name="TextBox 14"/>
+          <p:cNvSpPr txBox="1"/>
+          <p:nvPr/>
+        </p:nvSpPr>
+        <p:spPr>
+          <a:xfrm>
+            <a:off x="640080" y="3330702"/>
+            <a:ext cx="10908792" cy="285750"/>
+          </a:xfrm>
+          <a:prstGeom prst="rect">
+            <a:avLst/>
+          </a:prstGeom>
+          <a:noFill/>
+        </p:spPr>
+        <p:txBody>
+          <a:bodyPr wrap="square" lIns="0" rIns="0" tIns="0" bIns="0">
+            <a:spAutoFit/>
+          </a:bodyPr>
+          <a:lstStyle/>
+          <a:p>
+            <a:pPr algn="l"/>
+            <a:r>
+              <a:rPr sz="1200" b="0">
+                <a:solidFill>
+                  <a:srgbClr val="1A1A1A"/>
+                </a:solidFill>
+              </a:rPr>
+              <a:t>▪  "Unfreeze" (frozen state) — solid blue-600 fill, clearly signals a reversible recovery action</a:t>
+            </a:r>
+          </a:p>
+        </p:txBody>
+      </p:sp>
+      <p:sp>
+        <p:nvSpPr>
+          <p:cNvPr id="16" name="TextBox 15"/>
+          <p:cNvSpPr txBox="1"/>
+          <p:nvPr/>
+        </p:nvSpPr>
+        <p:spPr>
+          <a:xfrm>
+            <a:off x="457200" y="3689604"/>
+            <a:ext cx="11091672" cy="365760"/>
+          </a:xfrm>
+          <a:prstGeom prst="rect">
+            <a:avLst/>
+          </a:prstGeom>
+          <a:noFill/>
+        </p:spPr>
+        <p:txBody>
+          <a:bodyPr wrap="square" lIns="0" rIns="0" tIns="0" bIns="0">
+            <a:spAutoFit/>
+          </a:bodyPr>
+          <a:lstStyle/>
+          <a:p>
+            <a:pPr algn="l"/>
+            <a:r>
+              <a:rPr sz="1400" b="1">
+                <a:solidFill>
+                  <a:srgbClr val="C8102E"/>
+                </a:solidFill>
+              </a:rPr>
+              <a:t>Why it matters</a:t>
+            </a:r>
+          </a:p>
+        </p:txBody>
+      </p:sp>
+      <p:sp>
+        <p:nvSpPr>
+          <p:cNvPr id="17" name="TextBox 16"/>
+          <p:cNvSpPr txBox="1"/>
+          <p:nvPr/>
+        </p:nvSpPr>
+        <p:spPr>
+          <a:xfrm>
+            <a:off x="640080" y="4055364"/>
+            <a:ext cx="10908792" cy="285750"/>
+          </a:xfrm>
+          <a:prstGeom prst="rect">
+            <a:avLst/>
+          </a:prstGeom>
+          <a:noFill/>
+        </p:spPr>
+        <p:txBody>
+          <a:bodyPr wrap="square" lIns="0" rIns="0" tIns="0" bIns="0">
+            <a:spAutoFit/>
+          </a:bodyPr>
+          <a:lstStyle/>
+          <a:p>
+            <a:pPr algn="l"/>
+            <a:r>
+              <a:rPr sz="1200" b="0">
+                <a:solidFill>
+                  <a:srgbClr val="1A1A1A"/>
+                </a:solidFill>
+              </a:rPr>
+              <a:t>▪  Identical button weight is one of Refactoring UI's canonical anti-patterns. The new hierarchy</a:t>
+            </a:r>
+          </a:p>
+        </p:txBody>
+      </p:sp>
+      <p:sp>
+        <p:nvSpPr>
+          <p:cNvPr id="18" name="TextBox 17"/>
+          <p:cNvSpPr txBox="1"/>
+          <p:nvPr/>
+        </p:nvSpPr>
+        <p:spPr>
+          <a:xfrm>
+            <a:off x="640080" y="4341114"/>
+            <a:ext cx="10908792" cy="285750"/>
+          </a:xfrm>
+          <a:prstGeom prst="rect">
+            <a:avLst/>
+          </a:prstGeom>
+          <a:noFill/>
+        </p:spPr>
+        <p:txBody>
+          <a:bodyPr wrap="square" lIns="0" rIns="0" tIns="0" bIns="0">
+            <a:spAutoFit/>
+          </a:bodyPr>
+          <a:lstStyle/>
+          <a:p>
+            <a:pPr algn="l"/>
+            <a:r>
+              <a:rPr sz="1200" b="0">
+                <a:solidFill>
+                  <a:srgbClr val="1A1A1A"/>
+                </a:solidFill>
+              </a:rPr>
+              <a:t>▪  signals action severity at a glance and reduces accidental freezes in user testing.</a:t>
+            </a:r>
+          </a:p>
+        </p:txBody>
+      </p:sp>
+      <p:sp>
+        <p:nvSpPr>
+          <p:cNvPr id="19" name="Rectangle 18"/>
+          <p:cNvSpPr/>
+          <p:nvPr/>
+        </p:nvSpPr>
+        <p:spPr>
+          <a:xfrm>
+            <a:off x="457200" y="6217920"/>
+            <a:ext cx="11274552" cy="457200"/>
+          </a:xfrm>
+          <a:prstGeom prst="rect">
+            <a:avLst/>
+          </a:prstGeom>
+          <a:solidFill>
+            <a:srgbClr val="F5F0E8"/>
+          </a:solidFill>
+          <a:ln>
+            <a:noFill/>
+          </a:ln>
+        </p:spPr>
+        <p:style>
+          <a:lnRef idx="1">
+            <a:schemeClr val="accent1"/>
+          </a:lnRef>
+          <a:fillRef idx="3">
+            <a:schemeClr val="accent1"/>
+          </a:fillRef>
+          <a:effectRef idx="2">
+            <a:schemeClr val="accent1"/>
+          </a:effectRef>
+          <a:fontRef idx="minor">
+            <a:schemeClr val="lt1"/>
+          </a:fontRef>
+        </p:style>
+        <p:txBody>
+          <a:bodyPr rtlCol="0" anchor="ctr"/>
+          <a:lstStyle/>
+          <a:p>
+            <a:pPr algn="ctr"/>
+          </a:p>
+        </p:txBody>
+      </p:sp>
+      <p:sp>
+        <p:nvSpPr>
+          <p:cNvPr id="20" name="TextBox 19"/>
+          <p:cNvSpPr txBox="1"/>
+          <p:nvPr/>
+        </p:nvSpPr>
+        <p:spPr>
+          <a:xfrm>
+            <a:off x="640080" y="6263640"/>
+            <a:ext cx="11091672" cy="365760"/>
+          </a:xfrm>
+          <a:prstGeom prst="rect">
+            <a:avLst/>
+          </a:prstGeom>
+          <a:noFill/>
+        </p:spPr>
+        <p:txBody>
+          <a:bodyPr wrap="square" lIns="0" rIns="0" tIns="0" bIns="0">
+            <a:spAutoFit/>
+          </a:bodyPr>
+          <a:lstStyle/>
+          <a:p>
+            <a:pPr algn="l"/>
+            <a:r>
+              <a:rPr sz="1000" b="0">
+                <a:solidFill>
+                  <a:srgbClr val="78716C"/>
+                </a:solidFill>
+              </a:rPr>
+              <a:t>Session 2 · 23 Jun 2026  ·  Card buttons render block ~line 2600 (SavingsSheet / card section)</a:t>
+            </a:r>
+          </a:p>
+        </p:txBody>
+      </p:sp>
+    </p:spTree>
+  </p:cSld>
+  <p:clrMapOvr>
+    <a:masterClrMapping/>
+  </p:clrMapOvr>
+</p:sld>
+</file>
+
+<file path=ppt/slides/slide14.xml><?xml version="1.0" encoding="utf-8"?>
+<p:sld xmlns:a="http://schemas.openxmlformats.org/drawingml/2006/main" xmlns:p="http://schemas.openxmlformats.org/presentationml/2006/main" xmlns:r="http://schemas.openxmlformats.org/officeDocument/2006/relationships">
+  <p:cSld>
+    <p:spTree>
+      <p:nvGrpSpPr>
+        <p:cNvPr id="1" name=""/>
+        <p:cNvGrpSpPr/>
+        <p:nvPr/>
+      </p:nvGrpSpPr>
+      <p:grpSpPr/>
+      <p:sp>
+        <p:nvSpPr>
+          <p:cNvPr id="2" name="Rectangle 1"/>
+          <p:cNvSpPr/>
+          <p:nvPr/>
+        </p:nvSpPr>
+        <p:spPr>
+          <a:xfrm>
+            <a:off x="0" y="0"/>
+            <a:ext cx="12188952" cy="73152"/>
+          </a:xfrm>
+          <a:prstGeom prst="rect">
+            <a:avLst/>
+          </a:prstGeom>
+          <a:solidFill>
+            <a:srgbClr val="C8102E"/>
+          </a:solidFill>
+          <a:ln>
+            <a:noFill/>
+          </a:ln>
+        </p:spPr>
+        <p:style>
+          <a:lnRef idx="1">
+            <a:schemeClr val="accent1"/>
+          </a:lnRef>
+          <a:fillRef idx="3">
+            <a:schemeClr val="accent1"/>
+          </a:fillRef>
+          <a:effectRef idx="2">
+            <a:schemeClr val="accent1"/>
+          </a:effectRef>
+          <a:fontRef idx="minor">
+            <a:schemeClr val="lt1"/>
+          </a:fontRef>
+        </p:style>
+        <p:txBody>
+          <a:bodyPr rtlCol="0" anchor="ctr"/>
+          <a:lstStyle/>
+          <a:p>
+            <a:pPr algn="ctr"/>
+          </a:p>
+        </p:txBody>
+      </p:sp>
+      <p:sp>
+        <p:nvSpPr>
+          <p:cNvPr id="3" name="Rectangle 2"/>
+          <p:cNvSpPr/>
+          <p:nvPr/>
+        </p:nvSpPr>
+        <p:spPr>
+          <a:xfrm>
+            <a:off x="0" y="73152"/>
+            <a:ext cx="12188952" cy="6784848"/>
+          </a:xfrm>
+          <a:prstGeom prst="rect">
+            <a:avLst/>
+          </a:prstGeom>
+          <a:solidFill>
+            <a:srgbClr val="FAF6EF"/>
+          </a:solidFill>
+          <a:ln>
+            <a:noFill/>
+          </a:ln>
+        </p:spPr>
+        <p:style>
+          <a:lnRef idx="1">
+            <a:schemeClr val="accent1"/>
+          </a:lnRef>
+          <a:fillRef idx="3">
+            <a:schemeClr val="accent1"/>
+          </a:fillRef>
+          <a:effectRef idx="2">
+            <a:schemeClr val="accent1"/>
+          </a:effectRef>
+          <a:fontRef idx="minor">
+            <a:schemeClr val="lt1"/>
+          </a:fontRef>
+        </p:style>
+        <p:txBody>
+          <a:bodyPr rtlCol="0" anchor="ctr"/>
+          <a:lstStyle/>
+          <a:p>
+            <a:pPr algn="ctr"/>
+          </a:p>
+        </p:txBody>
+      </p:sp>
+      <p:sp>
+        <p:nvSpPr>
+          <p:cNvPr id="4" name="TextBox 3"/>
+          <p:cNvSpPr txBox="1"/>
+          <p:nvPr/>
+        </p:nvSpPr>
+        <p:spPr>
+          <a:xfrm>
+            <a:off x="457200" y="91152"/>
+            <a:ext cx="4000000" cy="320000"/>
+          </a:xfrm>
+          <a:prstGeom prst="rect">
+            <a:avLst/>
+          </a:prstGeom>
+          <a:noFill/>
+        </p:spPr>
+        <p:txBody>
+          <a:bodyPr wrap="square" lIns="0" rIns="0" tIns="0" bIns="0">
+            <a:spAutoFit/>
+          </a:bodyPr>
+          <a:lstStyle/>
+          <a:p>
+            <a:pPr algn="l"/>
+            <a:r>
+              <a:rPr sz="900" b="1">
+                <a:solidFill>
+                  <a:srgbClr val="C8102E"/>
+                </a:solidFill>
+              </a:rPr>
+              <a:t>SESSION 2  —  23 June 2026</a:t>
+            </a:r>
+          </a:p>
+        </p:txBody>
+      </p:sp>
+      <p:sp>
+        <p:nvSpPr>
+          <p:cNvPr id="5" name="TextBox 4"/>
+          <p:cNvSpPr txBox="1"/>
+          <p:nvPr/>
+        </p:nvSpPr>
+        <p:spPr>
+          <a:xfrm>
+            <a:off x="10931752" y="91152"/>
+            <a:ext cx="760000" cy="320000"/>
+          </a:xfrm>
+          <a:prstGeom prst="rect">
+            <a:avLst/>
+          </a:prstGeom>
+          <a:noFill/>
+        </p:spPr>
+        <p:txBody>
+          <a:bodyPr wrap="square" lIns="0" rIns="0" tIns="0" bIns="0">
+            <a:spAutoFit/>
+          </a:bodyPr>
+          <a:lstStyle/>
+          <a:p>
+            <a:pPr algn="r"/>
+            <a:r>
+              <a:rPr sz="900" b="0">
+                <a:solidFill>
+                  <a:srgbClr val="78716C"/>
+                </a:solidFill>
+              </a:rPr>
+              <a:t>14 / 15</a:t>
+            </a:r>
+          </a:p>
+        </p:txBody>
+      </p:sp>
+      <p:sp>
+        <p:nvSpPr>
+          <p:cNvPr id="6" name="TextBox 5"/>
+          <p:cNvSpPr txBox="1"/>
+          <p:nvPr/>
+        </p:nvSpPr>
+        <p:spPr>
+          <a:xfrm>
+            <a:off x="457200" y="228600"/>
+            <a:ext cx="11091672" cy="640080"/>
+          </a:xfrm>
+          <a:prstGeom prst="rect">
+            <a:avLst/>
+          </a:prstGeom>
+          <a:noFill/>
+        </p:spPr>
+        <p:txBody>
+          <a:bodyPr wrap="square" lIns="0" rIns="0" tIns="0" bIns="0">
+            <a:spAutoFit/>
+          </a:bodyPr>
+          <a:lstStyle/>
+          <a:p>
+            <a:pPr algn="l"/>
+            <a:r>
+              <a:rPr sz="2600" b="1">
+                <a:solidFill>
+                  <a:srgbClr val="1A1A1A"/>
+                </a:solidFill>
+              </a:rPr>
+              <a:t>Biometric Picker — Segmented Control Pattern</a:t>
+            </a:r>
+          </a:p>
+        </p:txBody>
+      </p:sp>
+      <p:sp>
+        <p:nvSpPr>
+          <p:cNvPr id="7" name="Rectangle 6"/>
+          <p:cNvSpPr/>
+          <p:nvPr/>
+        </p:nvSpPr>
+        <p:spPr>
+          <a:xfrm>
+            <a:off x="457200" y="868680"/>
+            <a:ext cx="11274552" cy="36576"/>
+          </a:xfrm>
+          <a:prstGeom prst="rect">
+            <a:avLst/>
+          </a:prstGeom>
+          <a:solidFill>
+            <a:srgbClr val="C8102E"/>
+          </a:solidFill>
+          <a:ln>
+            <a:noFill/>
+          </a:ln>
+        </p:spPr>
+        <p:style>
+          <a:lnRef idx="1">
+            <a:schemeClr val="accent1"/>
+          </a:lnRef>
+          <a:fillRef idx="3">
+            <a:schemeClr val="accent1"/>
+          </a:fillRef>
+          <a:effectRef idx="2">
+            <a:schemeClr val="accent1"/>
+          </a:effectRef>
+          <a:fontRef idx="minor">
+            <a:schemeClr val="lt1"/>
+          </a:fontRef>
+        </p:style>
+        <p:txBody>
+          <a:bodyPr rtlCol="0" anchor="ctr"/>
+          <a:lstStyle/>
+          <a:p>
+            <a:pPr algn="ctr"/>
+          </a:p>
+        </p:txBody>
+      </p:sp>
+      <p:sp>
+        <p:nvSpPr>
+          <p:cNvPr id="8" name="TextBox 7"/>
+          <p:cNvSpPr txBox="1"/>
+          <p:nvPr/>
+        </p:nvSpPr>
+        <p:spPr>
+          <a:xfrm>
+            <a:off x="457200" y="1097280"/>
+            <a:ext cx="11091672" cy="365760"/>
+          </a:xfrm>
+          <a:prstGeom prst="rect">
+            <a:avLst/>
+          </a:prstGeom>
+          <a:noFill/>
+        </p:spPr>
+        <p:txBody>
+          <a:bodyPr wrap="square" lIns="0" rIns="0" tIns="0" bIns="0">
+            <a:spAutoFit/>
+          </a:bodyPr>
+          <a:lstStyle/>
+          <a:p>
+            <a:pPr algn="l"/>
+            <a:r>
+              <a:rPr sz="1400" b="1">
+                <a:solidFill>
+                  <a:srgbClr val="C8102E"/>
+                </a:solidFill>
+              </a:rPr>
+              <a:t>Before</a:t>
+            </a:r>
+          </a:p>
+        </p:txBody>
+      </p:sp>
+      <p:sp>
+        <p:nvSpPr>
+          <p:cNvPr id="9" name="TextBox 8"/>
+          <p:cNvSpPr txBox="1"/>
+          <p:nvPr/>
+        </p:nvSpPr>
+        <p:spPr>
+          <a:xfrm>
+            <a:off x="640080" y="1463040"/>
+            <a:ext cx="10908792" cy="285750"/>
+          </a:xfrm>
+          <a:prstGeom prst="rect">
+            <a:avLst/>
+          </a:prstGeom>
+          <a:noFill/>
+        </p:spPr>
+        <p:txBody>
+          <a:bodyPr wrap="square" lIns="0" rIns="0" tIns="0" bIns="0">
+            <a:spAutoFit/>
+          </a:bodyPr>
+          <a:lstStyle/>
+          <a:p>
+            <a:pPr algn="l"/>
+            <a:r>
+              <a:rPr sz="1200" b="0">
+                <a:solidFill>
+                  <a:srgbClr val="1A1A1A"/>
+                </a:solidFill>
+              </a:rPr>
+              <a:t>▪  Flat colour tiles for Face ID / Touch ID / Voice ID with no clear selected-state affordance</a:t>
+            </a:r>
+          </a:p>
+        </p:txBody>
+      </p:sp>
+      <p:sp>
+        <p:nvSpPr>
+          <p:cNvPr id="10" name="TextBox 9"/>
+          <p:cNvSpPr txBox="1"/>
+          <p:nvPr/>
+        </p:nvSpPr>
+        <p:spPr>
+          <a:xfrm>
+            <a:off x="640080" y="1748790"/>
+            <a:ext cx="10908792" cy="285750"/>
+          </a:xfrm>
+          <a:prstGeom prst="rect">
+            <a:avLst/>
+          </a:prstGeom>
+          <a:noFill/>
+        </p:spPr>
+        <p:txBody>
+          <a:bodyPr wrap="square" lIns="0" rIns="0" tIns="0" bIns="0">
+            <a:spAutoFit/>
+          </a:bodyPr>
+          <a:lstStyle/>
+          <a:p>
+            <a:pPr algn="l"/>
+            <a:r>
+              <a:rPr sz="1200" b="0">
+                <a:solidFill>
+                  <a:srgbClr val="1A1A1A"/>
+                </a:solidFill>
+              </a:rPr>
+              <a:t>▪  All three options looked identical whether selected or not</a:t>
+            </a:r>
+          </a:p>
+        </p:txBody>
+      </p:sp>
+      <p:sp>
+        <p:nvSpPr>
+          <p:cNvPr id="11" name="TextBox 10"/>
+          <p:cNvSpPr txBox="1"/>
+          <p:nvPr/>
+        </p:nvSpPr>
+        <p:spPr>
+          <a:xfrm>
+            <a:off x="640080" y="2034540"/>
+            <a:ext cx="10908792" cy="285750"/>
+          </a:xfrm>
+          <a:prstGeom prst="rect">
+            <a:avLst/>
+          </a:prstGeom>
+          <a:noFill/>
+        </p:spPr>
+        <p:txBody>
+          <a:bodyPr wrap="square" lIns="0" rIns="0" tIns="0" bIns="0">
+            <a:spAutoFit/>
+          </a:bodyPr>
+          <a:lstStyle/>
+          <a:p>
+            <a:pPr algn="l"/>
+            <a:r>
+              <a:rPr sz="1200" b="0">
+                <a:solidFill>
+                  <a:srgbClr val="1A1A1A"/>
+                </a:solidFill>
+              </a:rPr>
+              <a:t>▪  No depth cue to indicate which option was active</a:t>
+            </a:r>
+          </a:p>
+        </p:txBody>
+      </p:sp>
+      <p:sp>
+        <p:nvSpPr>
+          <p:cNvPr id="12" name="TextBox 11"/>
+          <p:cNvSpPr txBox="1"/>
+          <p:nvPr/>
+        </p:nvSpPr>
+        <p:spPr>
+          <a:xfrm>
+            <a:off x="457200" y="2393442"/>
+            <a:ext cx="11091672" cy="365760"/>
+          </a:xfrm>
+          <a:prstGeom prst="rect">
+            <a:avLst/>
+          </a:prstGeom>
+          <a:noFill/>
+        </p:spPr>
+        <p:txBody>
+          <a:bodyPr wrap="square" lIns="0" rIns="0" tIns="0" bIns="0">
+            <a:spAutoFit/>
+          </a:bodyPr>
+          <a:lstStyle/>
+          <a:p>
+            <a:pPr algn="l"/>
+            <a:r>
+              <a:rPr sz="1400" b="1">
+                <a:solidFill>
+                  <a:srgbClr val="C8102E"/>
+                </a:solidFill>
+              </a:rPr>
+              <a:t>After</a:t>
+            </a:r>
+          </a:p>
+        </p:txBody>
+      </p:sp>
+      <p:sp>
+        <p:nvSpPr>
+          <p:cNvPr id="13" name="TextBox 12"/>
+          <p:cNvSpPr txBox="1"/>
+          <p:nvPr/>
+        </p:nvSpPr>
+        <p:spPr>
+          <a:xfrm>
+            <a:off x="640080" y="2759202"/>
+            <a:ext cx="10908792" cy="285750"/>
+          </a:xfrm>
+          <a:prstGeom prst="rect">
+            <a:avLst/>
+          </a:prstGeom>
+          <a:noFill/>
+        </p:spPr>
+        <p:txBody>
+          <a:bodyPr wrap="square" lIns="0" rIns="0" tIns="0" bIns="0">
+            <a:spAutoFit/>
+          </a:bodyPr>
+          <a:lstStyle/>
+          <a:p>
+            <a:pPr algn="l"/>
+            <a:r>
+              <a:rPr sz="1200" b="0">
+                <a:solidFill>
+                  <a:srgbClr val="1A1A1A"/>
+                </a:solidFill>
+              </a:rPr>
+              <a:t>▪  Grey track (stone-100 background) containing three equal-width segments</a:t>
+            </a:r>
+          </a:p>
+        </p:txBody>
+      </p:sp>
+      <p:sp>
+        <p:nvSpPr>
+          <p:cNvPr id="14" name="TextBox 13"/>
+          <p:cNvSpPr txBox="1"/>
+          <p:nvPr/>
+        </p:nvSpPr>
+        <p:spPr>
+          <a:xfrm>
+            <a:off x="640080" y="3044952"/>
+            <a:ext cx="10908792" cy="285750"/>
+          </a:xfrm>
+          <a:prstGeom prst="rect">
+            <a:avLst/>
+          </a:prstGeom>
+          <a:noFill/>
+        </p:spPr>
+        <p:txBody>
+          <a:bodyPr wrap="square" lIns="0" rIns="0" tIns="0" bIns="0">
+            <a:spAutoFit/>
+          </a:bodyPr>
+          <a:lstStyle/>
+          <a:p>
+            <a:pPr algn="l"/>
+            <a:r>
+              <a:rPr sz="1200" b="0">
+                <a:solidFill>
+                  <a:srgbClr val="1A1A1A"/>
+                </a:solidFill>
+              </a:rPr>
+              <a:t>▪  Active state: the selected segment lifts as a white card with drop shadow + stone-200 border</a:t>
+            </a:r>
+          </a:p>
+        </p:txBody>
+      </p:sp>
+      <p:sp>
+        <p:nvSpPr>
+          <p:cNvPr id="15" name="TextBox 14"/>
+          <p:cNvSpPr txBox="1"/>
+          <p:nvPr/>
+        </p:nvSpPr>
+        <p:spPr>
+          <a:xfrm>
+            <a:off x="640080" y="3330702"/>
+            <a:ext cx="10908792" cy="285750"/>
+          </a:xfrm>
+          <a:prstGeom prst="rect">
+            <a:avLst/>
+          </a:prstGeom>
+          <a:noFill/>
+        </p:spPr>
+        <p:txBody>
+          <a:bodyPr wrap="square" lIns="0" rIns="0" tIns="0" bIns="0">
+            <a:spAutoFit/>
+          </a:bodyPr>
+          <a:lstStyle/>
+          <a:p>
+            <a:pPr algn="l"/>
+            <a:r>
+              <a:rPr sz="1200" b="0">
+                <a:solidFill>
+                  <a:srgbClr val="1A1A1A"/>
+                </a:solidFill>
+              </a:rPr>
+              <a:t>▪  Inactive segments sit flush in the track — classic iOS-style segmented control pattern</a:t>
+            </a:r>
+          </a:p>
+        </p:txBody>
+      </p:sp>
+      <p:sp>
+        <p:nvSpPr>
+          <p:cNvPr id="16" name="TextBox 15"/>
+          <p:cNvSpPr txBox="1"/>
+          <p:nvPr/>
+        </p:nvSpPr>
+        <p:spPr>
+          <a:xfrm>
+            <a:off x="640080" y="3616452"/>
+            <a:ext cx="10908792" cy="285750"/>
+          </a:xfrm>
+          <a:prstGeom prst="rect">
+            <a:avLst/>
+          </a:prstGeom>
+          <a:noFill/>
+        </p:spPr>
+        <p:txBody>
+          <a:bodyPr wrap="square" lIns="0" rIns="0" tIns="0" bIns="0">
+            <a:spAutoFit/>
+          </a:bodyPr>
+          <a:lstStyle/>
+          <a:p>
+            <a:pPr algn="l"/>
+            <a:r>
+              <a:rPr sz="1200" b="0">
+                <a:solidFill>
+                  <a:srgbClr val="1A1A1A"/>
+                </a:solidFill>
+              </a:rPr>
+              <a:t>▪  Three options preserved: Face ID  /  Touch ID  /  Voice ID</a:t>
+            </a:r>
+          </a:p>
+        </p:txBody>
+      </p:sp>
+      <p:sp>
+        <p:nvSpPr>
+          <p:cNvPr id="17" name="TextBox 16"/>
+          <p:cNvSpPr txBox="1"/>
+          <p:nvPr/>
+        </p:nvSpPr>
+        <p:spPr>
+          <a:xfrm>
+            <a:off x="457200" y="3975354"/>
+            <a:ext cx="11091672" cy="365760"/>
+          </a:xfrm>
+          <a:prstGeom prst="rect">
+            <a:avLst/>
+          </a:prstGeom>
+          <a:noFill/>
+        </p:spPr>
+        <p:txBody>
+          <a:bodyPr wrap="square" lIns="0" rIns="0" tIns="0" bIns="0">
+            <a:spAutoFit/>
+          </a:bodyPr>
+          <a:lstStyle/>
+          <a:p>
+            <a:pPr algn="l"/>
+            <a:r>
+              <a:rPr sz="1400" b="1">
+                <a:solidFill>
+                  <a:srgbClr val="C8102E"/>
+                </a:solidFill>
+              </a:rPr>
+              <a:t>Why it matters</a:t>
+            </a:r>
+          </a:p>
+        </p:txBody>
+      </p:sp>
+      <p:sp>
+        <p:nvSpPr>
+          <p:cNvPr id="18" name="TextBox 17"/>
+          <p:cNvSpPr txBox="1"/>
+          <p:nvPr/>
+        </p:nvSpPr>
+        <p:spPr>
+          <a:xfrm>
+            <a:off x="640080" y="4341114"/>
+            <a:ext cx="10908792" cy="285750"/>
+          </a:xfrm>
+          <a:prstGeom prst="rect">
+            <a:avLst/>
+          </a:prstGeom>
+          <a:noFill/>
+        </p:spPr>
+        <p:txBody>
+          <a:bodyPr wrap="square" lIns="0" rIns="0" tIns="0" bIns="0">
+            <a:spAutoFit/>
+          </a:bodyPr>
+          <a:lstStyle/>
+          <a:p>
+            <a:pPr algn="l"/>
+            <a:r>
+              <a:rPr sz="1200" b="0">
+                <a:solidFill>
+                  <a:srgbClr val="1A1A1A"/>
+                </a:solidFill>
+              </a:rPr>
+              <a:t>▪  The segmented control is a well-established mobile pattern for mutually exclusive choices.</a:t>
+            </a:r>
+          </a:p>
+        </p:txBody>
+      </p:sp>
+      <p:sp>
+        <p:nvSpPr>
+          <p:cNvPr id="19" name="TextBox 18"/>
+          <p:cNvSpPr txBox="1"/>
+          <p:nvPr/>
+        </p:nvSpPr>
+        <p:spPr>
+          <a:xfrm>
+            <a:off x="640080" y="4626864"/>
+            <a:ext cx="10908792" cy="285750"/>
+          </a:xfrm>
+          <a:prstGeom prst="rect">
+            <a:avLst/>
+          </a:prstGeom>
+          <a:noFill/>
+        </p:spPr>
+        <p:txBody>
+          <a:bodyPr wrap="square" lIns="0" rIns="0" tIns="0" bIns="0">
+            <a:spAutoFit/>
+          </a:bodyPr>
+          <a:lstStyle/>
+          <a:p>
+            <a:pPr algn="l"/>
+            <a:r>
+              <a:rPr sz="1200" b="0">
+                <a:solidFill>
+                  <a:srgbClr val="1A1A1A"/>
+                </a:solidFill>
+              </a:rPr>
+              <a:t>▪  The lifted-card active state is immediately legible without colour dependency (accessibility win).</a:t>
+            </a:r>
+          </a:p>
+        </p:txBody>
+      </p:sp>
+      <p:sp>
+        <p:nvSpPr>
+          <p:cNvPr id="20" name="Rectangle 19"/>
+          <p:cNvSpPr/>
+          <p:nvPr/>
+        </p:nvSpPr>
+        <p:spPr>
+          <a:xfrm>
+            <a:off x="457200" y="6217920"/>
+            <a:ext cx="11274552" cy="457200"/>
+          </a:xfrm>
+          <a:prstGeom prst="rect">
+            <a:avLst/>
+          </a:prstGeom>
+          <a:solidFill>
+            <a:srgbClr val="F5F0E8"/>
+          </a:solidFill>
+          <a:ln>
+            <a:noFill/>
+          </a:ln>
+        </p:spPr>
+        <p:style>
+          <a:lnRef idx="1">
+            <a:schemeClr val="accent1"/>
+          </a:lnRef>
+          <a:fillRef idx="3">
+            <a:schemeClr val="accent1"/>
+          </a:fillRef>
+          <a:effectRef idx="2">
+            <a:schemeClr val="accent1"/>
+          </a:effectRef>
+          <a:fontRef idx="minor">
+            <a:schemeClr val="lt1"/>
+          </a:fontRef>
+        </p:style>
+        <p:txBody>
+          <a:bodyPr rtlCol="0" anchor="ctr"/>
+          <a:lstStyle/>
+          <a:p>
+            <a:pPr algn="ctr"/>
+          </a:p>
+        </p:txBody>
+      </p:sp>
+      <p:sp>
+        <p:nvSpPr>
+          <p:cNvPr id="21" name="TextBox 20"/>
+          <p:cNvSpPr txBox="1"/>
+          <p:nvPr/>
+        </p:nvSpPr>
+        <p:spPr>
+          <a:xfrm>
+            <a:off x="640080" y="6263640"/>
+            <a:ext cx="11091672" cy="365760"/>
+          </a:xfrm>
+          <a:prstGeom prst="rect">
+            <a:avLst/>
+          </a:prstGeom>
+          <a:noFill/>
+        </p:spPr>
+        <p:txBody>
+          <a:bodyPr wrap="square" lIns="0" rIns="0" tIns="0" bIns="0">
+            <a:spAutoFit/>
+          </a:bodyPr>
+          <a:lstStyle/>
+          <a:p>
+            <a:pPr algn="l"/>
+            <a:r>
+              <a:rPr sz="1000" b="0">
+                <a:solidFill>
+                  <a:srgbClr val="78716C"/>
+                </a:solidFill>
+              </a:rPr>
+              <a:t>Session 2 · 23 Jun 2026  ·  Biometric picker ~line 2390 (renderIdCheck / VoiceIdSheet)</a:t>
+            </a:r>
+          </a:p>
+        </p:txBody>
+      </p:sp>
+    </p:spTree>
+  </p:cSld>
+  <p:clrMapOvr>
+    <a:masterClrMapping/>
+  </p:clrMapOvr>
+</p:sld>
+</file>
+
+<file path=ppt/slides/slide15.xml><?xml version="1.0" encoding="utf-8"?>
+<p:sld xmlns:a="http://schemas.openxmlformats.org/drawingml/2006/main" xmlns:p="http://schemas.openxmlformats.org/presentationml/2006/main" xmlns:r="http://schemas.openxmlformats.org/officeDocument/2006/relationships">
+  <p:cSld>
+    <p:spTree>
+      <p:nvGrpSpPr>
+        <p:cNvPr id="1" name=""/>
+        <p:cNvGrpSpPr/>
+        <p:nvPr/>
+      </p:nvGrpSpPr>
+      <p:grpSpPr/>
+      <p:sp>
+        <p:nvSpPr>
+          <p:cNvPr id="2" name="Rectangle 1"/>
+          <p:cNvSpPr/>
+          <p:nvPr/>
+        </p:nvSpPr>
+        <p:spPr>
+          <a:xfrm>
+            <a:off x="0" y="0"/>
+            <a:ext cx="12188952" cy="73152"/>
+          </a:xfrm>
+          <a:prstGeom prst="rect">
+            <a:avLst/>
+          </a:prstGeom>
+          <a:solidFill>
+            <a:srgbClr val="C8102E"/>
+          </a:solidFill>
+          <a:ln>
+            <a:noFill/>
+          </a:ln>
+        </p:spPr>
+        <p:style>
+          <a:lnRef idx="1">
+            <a:schemeClr val="accent1"/>
+          </a:lnRef>
+          <a:fillRef idx="3">
+            <a:schemeClr val="accent1"/>
+          </a:fillRef>
+          <a:effectRef idx="2">
+            <a:schemeClr val="accent1"/>
+          </a:effectRef>
+          <a:fontRef idx="minor">
+            <a:schemeClr val="lt1"/>
+          </a:fontRef>
+        </p:style>
+        <p:txBody>
+          <a:bodyPr rtlCol="0" anchor="ctr"/>
+          <a:lstStyle/>
+          <a:p>
+            <a:pPr algn="ctr"/>
+          </a:p>
+        </p:txBody>
+      </p:sp>
+      <p:sp>
+        <p:nvSpPr>
+          <p:cNvPr id="3" name="Rectangle 2"/>
+          <p:cNvSpPr/>
+          <p:nvPr/>
+        </p:nvSpPr>
+        <p:spPr>
+          <a:xfrm>
+            <a:off x="0" y="73152"/>
+            <a:ext cx="12188952" cy="6784848"/>
+          </a:xfrm>
+          <a:prstGeom prst="rect">
+            <a:avLst/>
+          </a:prstGeom>
+          <a:solidFill>
+            <a:srgbClr val="FAF6EF"/>
+          </a:solidFill>
+          <a:ln>
+            <a:noFill/>
+          </a:ln>
+        </p:spPr>
+        <p:style>
+          <a:lnRef idx="1">
+            <a:schemeClr val="accent1"/>
+          </a:lnRef>
+          <a:fillRef idx="3">
+            <a:schemeClr val="accent1"/>
+          </a:fillRef>
+          <a:effectRef idx="2">
+            <a:schemeClr val="accent1"/>
+          </a:effectRef>
+          <a:fontRef idx="minor">
+            <a:schemeClr val="lt1"/>
+          </a:fontRef>
+        </p:style>
+        <p:txBody>
+          <a:bodyPr rtlCol="0" anchor="ctr"/>
+          <a:lstStyle/>
+          <a:p>
+            <a:pPr algn="ctr"/>
+          </a:p>
+        </p:txBody>
+      </p:sp>
+      <p:sp>
+        <p:nvSpPr>
+          <p:cNvPr id="4" name="TextBox 3"/>
+          <p:cNvSpPr txBox="1"/>
+          <p:nvPr/>
+        </p:nvSpPr>
+        <p:spPr>
+          <a:xfrm>
+            <a:off x="457200" y="91152"/>
+            <a:ext cx="4000000" cy="320000"/>
+          </a:xfrm>
+          <a:prstGeom prst="rect">
+            <a:avLst/>
+          </a:prstGeom>
+          <a:noFill/>
+        </p:spPr>
+        <p:txBody>
+          <a:bodyPr wrap="square" lIns="0" rIns="0" tIns="0" bIns="0">
+            <a:spAutoFit/>
+          </a:bodyPr>
+          <a:lstStyle/>
+          <a:p>
+            <a:pPr algn="l"/>
+            <a:r>
+              <a:rPr sz="900" b="1">
+                <a:solidFill>
+                  <a:srgbClr val="C8102E"/>
+                </a:solidFill>
+              </a:rPr>
+              <a:t>SESSION 2  —  23 June 2026</a:t>
+            </a:r>
+          </a:p>
+        </p:txBody>
+      </p:sp>
+      <p:sp>
+        <p:nvSpPr>
+          <p:cNvPr id="5" name="TextBox 4"/>
+          <p:cNvSpPr txBox="1"/>
+          <p:nvPr/>
+        </p:nvSpPr>
+        <p:spPr>
+          <a:xfrm>
+            <a:off x="10931752" y="91152"/>
+            <a:ext cx="760000" cy="320000"/>
+          </a:xfrm>
+          <a:prstGeom prst="rect">
+            <a:avLst/>
+          </a:prstGeom>
+          <a:noFill/>
+        </p:spPr>
+        <p:txBody>
+          <a:bodyPr wrap="square" lIns="0" rIns="0" tIns="0" bIns="0">
+            <a:spAutoFit/>
+          </a:bodyPr>
+          <a:lstStyle/>
+          <a:p>
+            <a:pPr algn="r"/>
+            <a:r>
+              <a:rPr sz="900" b="0">
+                <a:solidFill>
+                  <a:srgbClr val="78716C"/>
+                </a:solidFill>
+              </a:rPr>
+              <a:t>15 / 15</a:t>
+            </a:r>
+          </a:p>
+        </p:txBody>
+      </p:sp>
+      <p:sp>
+        <p:nvSpPr>
+          <p:cNvPr id="6" name="TextBox 5"/>
+          <p:cNvSpPr txBox="1"/>
+          <p:nvPr/>
+        </p:nvSpPr>
+        <p:spPr>
+          <a:xfrm>
+            <a:off x="457200" y="228600"/>
+            <a:ext cx="11091672" cy="640080"/>
+          </a:xfrm>
+          <a:prstGeom prst="rect">
+            <a:avLst/>
+          </a:prstGeom>
+          <a:noFill/>
+        </p:spPr>
+        <p:txBody>
+          <a:bodyPr wrap="square" lIns="0" rIns="0" tIns="0" bIns="0">
+            <a:spAutoFit/>
+          </a:bodyPr>
+          <a:lstStyle/>
+          <a:p>
+            <a:pPr algn="l"/>
+            <a:r>
+              <a:rPr sz="2600" b="1">
+                <a:solidFill>
+                  <a:srgbClr val="1A1A1A"/>
+                </a:solidFill>
+              </a:rPr>
+              <a:t>VAT Countdown Overlay — Calm Redesign</a:t>
+            </a:r>
+          </a:p>
+        </p:txBody>
+      </p:sp>
+      <p:sp>
+        <p:nvSpPr>
+          <p:cNvPr id="7" name="Rectangle 6"/>
+          <p:cNvSpPr/>
+          <p:nvPr/>
+        </p:nvSpPr>
+        <p:spPr>
+          <a:xfrm>
+            <a:off x="457200" y="868680"/>
+            <a:ext cx="11274552" cy="36576"/>
+          </a:xfrm>
+          <a:prstGeom prst="rect">
+            <a:avLst/>
+          </a:prstGeom>
+          <a:solidFill>
+            <a:srgbClr val="C8102E"/>
+          </a:solidFill>
+          <a:ln>
+            <a:noFill/>
+          </a:ln>
+        </p:spPr>
+        <p:style>
+          <a:lnRef idx="1">
+            <a:schemeClr val="accent1"/>
+          </a:lnRef>
+          <a:fillRef idx="3">
+            <a:schemeClr val="accent1"/>
+          </a:fillRef>
+          <a:effectRef idx="2">
+            <a:schemeClr val="accent1"/>
+          </a:effectRef>
+          <a:fontRef idx="minor">
+            <a:schemeClr val="lt1"/>
+          </a:fontRef>
+        </p:style>
+        <p:txBody>
+          <a:bodyPr rtlCol="0" anchor="ctr"/>
+          <a:lstStyle/>
+          <a:p>
+            <a:pPr algn="ctr"/>
+          </a:p>
+        </p:txBody>
+      </p:sp>
+      <p:sp>
+        <p:nvSpPr>
+          <p:cNvPr id="8" name="TextBox 7"/>
+          <p:cNvSpPr txBox="1"/>
+          <p:nvPr/>
+        </p:nvSpPr>
+        <p:spPr>
+          <a:xfrm>
+            <a:off x="457200" y="1097280"/>
+            <a:ext cx="11091672" cy="365760"/>
+          </a:xfrm>
+          <a:prstGeom prst="rect">
+            <a:avLst/>
+          </a:prstGeom>
+          <a:noFill/>
+        </p:spPr>
+        <p:txBody>
+          <a:bodyPr wrap="square" lIns="0" rIns="0" tIns="0" bIns="0">
+            <a:spAutoFit/>
+          </a:bodyPr>
+          <a:lstStyle/>
+          <a:p>
+            <a:pPr algn="l"/>
+            <a:r>
+              <a:rPr sz="1400" b="1">
+                <a:solidFill>
+                  <a:srgbClr val="C8102E"/>
+                </a:solidFill>
+              </a:rPr>
+              <a:t>Before</a:t>
+            </a:r>
+          </a:p>
+        </p:txBody>
+      </p:sp>
+      <p:sp>
+        <p:nvSpPr>
+          <p:cNvPr id="9" name="TextBox 8"/>
+          <p:cNvSpPr txBox="1"/>
+          <p:nvPr/>
+        </p:nvSpPr>
+        <p:spPr>
+          <a:xfrm>
+            <a:off x="640080" y="1463040"/>
+            <a:ext cx="10908792" cy="285750"/>
+          </a:xfrm>
+          <a:prstGeom prst="rect">
+            <a:avLst/>
+          </a:prstGeom>
+          <a:noFill/>
+        </p:spPr>
+        <p:txBody>
+          <a:bodyPr wrap="square" lIns="0" rIns="0" tIns="0" bIns="0">
+            <a:spAutoFit/>
+          </a:bodyPr>
+          <a:lstStyle/>
+          <a:p>
+            <a:pPr algn="l"/>
+            <a:r>
+              <a:rPr sz="1200" b="0">
+                <a:solidFill>
+                  <a:srgbClr val="1A1A1A"/>
+                </a:solidFill>
+              </a:rPr>
+              <a:t>▪  Header read 'One last chance to stop' — alarming, adversarial framing</a:t>
+            </a:r>
+          </a:p>
+        </p:txBody>
+      </p:sp>
+      <p:sp>
+        <p:nvSpPr>
+          <p:cNvPr id="10" name="TextBox 9"/>
+          <p:cNvSpPr txBox="1"/>
+          <p:nvPr/>
+        </p:nvSpPr>
+        <p:spPr>
+          <a:xfrm>
+            <a:off x="640080" y="1748790"/>
+            <a:ext cx="10908792" cy="285750"/>
+          </a:xfrm>
+          <a:prstGeom prst="rect">
+            <a:avLst/>
+          </a:prstGeom>
+          <a:noFill/>
+        </p:spPr>
+        <p:txBody>
+          <a:bodyPr wrap="square" lIns="0" rIns="0" tIns="0" bIns="0">
+            <a:spAutoFit/>
+          </a:bodyPr>
+          <a:lstStyle/>
+          <a:p>
+            <a:pPr algn="l"/>
+            <a:r>
+              <a:rPr sz="1200" b="0">
+                <a:solidFill>
+                  <a:srgbClr val="1A1A1A"/>
+                </a:solidFill>
+              </a:rPr>
+              <a:t>▪  Cancel button used brand red (#C8102E) — visually screamed danger for a routine cancel</a:t>
+            </a:r>
+          </a:p>
+        </p:txBody>
+      </p:sp>
+      <p:sp>
+        <p:nvSpPr>
+          <p:cNvPr id="11" name="TextBox 10"/>
+          <p:cNvSpPr txBox="1"/>
+          <p:nvPr/>
+        </p:nvSpPr>
+        <p:spPr>
+          <a:xfrm>
+            <a:off x="640080" y="2034540"/>
+            <a:ext cx="10908792" cy="285750"/>
+          </a:xfrm>
+          <a:prstGeom prst="rect">
+            <a:avLst/>
+          </a:prstGeom>
+          <a:noFill/>
+        </p:spPr>
+        <p:txBody>
+          <a:bodyPr wrap="square" lIns="0" rIns="0" tIns="0" bIns="0">
+            <a:spAutoFit/>
+          </a:bodyPr>
+          <a:lstStyle/>
+          <a:p>
+            <a:pPr algn="l"/>
+            <a:r>
+              <a:rPr sz="1200" b="0">
+                <a:solidFill>
+                  <a:srgbClr val="1A1A1A"/>
+                </a:solidFill>
+              </a:rPr>
+              <a:t>▪  Countdown ring radius r=42 with no unit label beneath the seconds number</a:t>
+            </a:r>
+          </a:p>
+        </p:txBody>
+      </p:sp>
+      <p:sp>
+        <p:nvSpPr>
+          <p:cNvPr id="12" name="TextBox 11"/>
+          <p:cNvSpPr txBox="1"/>
+          <p:nvPr/>
+        </p:nvSpPr>
+        <p:spPr>
+          <a:xfrm>
+            <a:off x="640080" y="2320290"/>
+            <a:ext cx="10908792" cy="285750"/>
+          </a:xfrm>
+          <a:prstGeom prst="rect">
+            <a:avLst/>
+          </a:prstGeom>
+          <a:noFill/>
+        </p:spPr>
+        <p:txBody>
+          <a:bodyPr wrap="square" lIns="0" rIns="0" tIns="0" bIns="0">
+            <a:spAutoFit/>
+          </a:bodyPr>
+          <a:lstStyle/>
+          <a:p>
+            <a:pPr algn="l"/>
+            <a:r>
+              <a:rPr sz="1200" b="0">
+                <a:solidFill>
+                  <a:srgbClr val="1A1A1A"/>
+                </a:solidFill>
+              </a:rPr>
+              <a:t>▪  HMRC warning was verbose and lacked visual containment</a:t>
+            </a:r>
+          </a:p>
+        </p:txBody>
+      </p:sp>
+      <p:sp>
+        <p:nvSpPr>
+          <p:cNvPr id="13" name="TextBox 12"/>
+          <p:cNvSpPr txBox="1"/>
+          <p:nvPr/>
+        </p:nvSpPr>
+        <p:spPr>
+          <a:xfrm>
+            <a:off x="457200" y="2679192"/>
+            <a:ext cx="11091672" cy="365760"/>
+          </a:xfrm>
+          <a:prstGeom prst="rect">
+            <a:avLst/>
+          </a:prstGeom>
+          <a:noFill/>
+        </p:spPr>
+        <p:txBody>
+          <a:bodyPr wrap="square" lIns="0" rIns="0" tIns="0" bIns="0">
+            <a:spAutoFit/>
+          </a:bodyPr>
+          <a:lstStyle/>
+          <a:p>
+            <a:pPr algn="l"/>
+            <a:r>
+              <a:rPr sz="1400" b="1">
+                <a:solidFill>
+                  <a:srgbClr val="C8102E"/>
+                </a:solidFill>
+              </a:rPr>
+              <a:t>After</a:t>
+            </a:r>
+          </a:p>
+        </p:txBody>
+      </p:sp>
+      <p:sp>
+        <p:nvSpPr>
+          <p:cNvPr id="14" name="TextBox 13"/>
+          <p:cNvSpPr txBox="1"/>
+          <p:nvPr/>
+        </p:nvSpPr>
+        <p:spPr>
+          <a:xfrm>
+            <a:off x="640080" y="3044952"/>
+            <a:ext cx="10908792" cy="285750"/>
+          </a:xfrm>
+          <a:prstGeom prst="rect">
+            <a:avLst/>
+          </a:prstGeom>
+          <a:noFill/>
+        </p:spPr>
+        <p:txBody>
+          <a:bodyPr wrap="square" lIns="0" rIns="0" tIns="0" bIns="0">
+            <a:spAutoFit/>
+          </a:bodyPr>
+          <a:lstStyle/>
+          <a:p>
+            <a:pPr algn="l"/>
+            <a:r>
+              <a:rPr sz="1200" b="0">
+                <a:solidFill>
+                  <a:srgbClr val="1A1A1A"/>
+                </a:solidFill>
+              </a:rPr>
+              <a:t>▪  Header changed to 'Filing your VAT return' — confident, process-oriented framing</a:t>
+            </a:r>
+          </a:p>
+        </p:txBody>
+      </p:sp>
+      <p:sp>
+        <p:nvSpPr>
+          <p:cNvPr id="15" name="TextBox 14"/>
+          <p:cNvSpPr txBox="1"/>
+          <p:nvPr/>
+        </p:nvSpPr>
+        <p:spPr>
+          <a:xfrm>
+            <a:off x="640080" y="3330702"/>
+            <a:ext cx="10908792" cy="285750"/>
+          </a:xfrm>
+          <a:prstGeom prst="rect">
+            <a:avLst/>
+          </a:prstGeom>
+          <a:noFill/>
+        </p:spPr>
+        <p:txBody>
+          <a:bodyPr wrap="square" lIns="0" rIns="0" tIns="0" bIns="0">
+            <a:spAutoFit/>
+          </a:bodyPr>
+          <a:lstStyle/>
+          <a:p>
+            <a:pPr algn="l"/>
+            <a:r>
+              <a:rPr sz="1200" b="0">
+                <a:solidFill>
+                  <a:srgbClr val="1A1A1A"/>
+                </a:solidFill>
+              </a:rPr>
+              <a:t>▪  Cancel button: calm stone-100 background / stone-700 text — clearly secondary, non-alarming</a:t>
+            </a:r>
+          </a:p>
+        </p:txBody>
+      </p:sp>
+      <p:sp>
+        <p:nvSpPr>
+          <p:cNvPr id="16" name="TextBox 15"/>
+          <p:cNvSpPr txBox="1"/>
+          <p:nvPr/>
+        </p:nvSpPr>
+        <p:spPr>
+          <a:xfrm>
+            <a:off x="640080" y="3616452"/>
+            <a:ext cx="10908792" cy="285750"/>
+          </a:xfrm>
+          <a:prstGeom prst="rect">
+            <a:avLst/>
+          </a:prstGeom>
+          <a:noFill/>
+        </p:spPr>
+        <p:txBody>
+          <a:bodyPr wrap="square" lIns="0" rIns="0" tIns="0" bIns="0">
+            <a:spAutoFit/>
+          </a:bodyPr>
+          <a:lstStyle/>
+          <a:p>
+            <a:pPr algn="l"/>
+            <a:r>
+              <a:rPr sz="1200" b="0">
+                <a:solidFill>
+                  <a:srgbClr val="1A1A1A"/>
+                </a:solidFill>
+              </a:rPr>
+              <a:t>▪  Ring enlarged from r=42 to r=46; 'sec' label added beneath the countdown number</a:t>
+            </a:r>
+          </a:p>
+        </p:txBody>
+      </p:sp>
+      <p:sp>
+        <p:nvSpPr>
+          <p:cNvPr id="17" name="TextBox 16"/>
+          <p:cNvSpPr txBox="1"/>
+          <p:nvPr/>
+        </p:nvSpPr>
+        <p:spPr>
+          <a:xfrm>
+            <a:off x="640080" y="3902202"/>
+            <a:ext cx="10908792" cy="285750"/>
+          </a:xfrm>
+          <a:prstGeom prst="rect">
+            <a:avLst/>
+          </a:prstGeom>
+          <a:noFill/>
+        </p:spPr>
+        <p:txBody>
+          <a:bodyPr wrap="square" lIns="0" rIns="0" tIns="0" bIns="0">
+            <a:spAutoFit/>
+          </a:bodyPr>
+          <a:lstStyle/>
+          <a:p>
+            <a:pPr algn="l"/>
+            <a:r>
+              <a:rPr sz="1200" b="0">
+                <a:solidFill>
+                  <a:srgbClr val="1A1A1A"/>
+                </a:solidFill>
+              </a:rPr>
+              <a:t>▪  Tax amount + label moved into a left-aligned stone-50 detail pill for clarity</a:t>
+            </a:r>
+          </a:p>
+        </p:txBody>
+      </p:sp>
+      <p:sp>
+        <p:nvSpPr>
+          <p:cNvPr id="18" name="TextBox 17"/>
+          <p:cNvSpPr txBox="1"/>
+          <p:nvPr/>
+        </p:nvSpPr>
+        <p:spPr>
+          <a:xfrm>
+            <a:off x="640080" y="4187952"/>
+            <a:ext cx="10908792" cy="285750"/>
+          </a:xfrm>
+          <a:prstGeom prst="rect">
+            <a:avLst/>
+          </a:prstGeom>
+          <a:noFill/>
+        </p:spPr>
+        <p:txBody>
+          <a:bodyPr wrap="square" lIns="0" rIns="0" tIns="0" bIns="0">
+            <a:spAutoFit/>
+          </a:bodyPr>
+          <a:lstStyle/>
+          <a:p>
+            <a:pPr algn="l"/>
+            <a:r>
+              <a:rPr sz="1200" b="0">
+                <a:solidFill>
+                  <a:srgbClr val="1A1A1A"/>
+                </a:solidFill>
+              </a:rPr>
+              <a:t>▪  HMRC amber warning shortened and given a visible border for containment</a:t>
+            </a:r>
+          </a:p>
+        </p:txBody>
+      </p:sp>
+      <p:sp>
+        <p:nvSpPr>
+          <p:cNvPr id="19" name="TextBox 18"/>
+          <p:cNvSpPr txBox="1"/>
+          <p:nvPr/>
+        </p:nvSpPr>
+        <p:spPr>
+          <a:xfrm>
+            <a:off x="640080" y="4473702"/>
+            <a:ext cx="10908792" cy="285750"/>
+          </a:xfrm>
+          <a:prstGeom prst="rect">
+            <a:avLst/>
+          </a:prstGeom>
+          <a:noFill/>
+        </p:spPr>
+        <p:txBody>
+          <a:bodyPr wrap="square" lIns="0" rIns="0" tIns="0" bIns="0">
+            <a:spAutoFit/>
+          </a:bodyPr>
+          <a:lstStyle/>
+          <a:p>
+            <a:pPr algn="l"/>
+            <a:r>
+              <a:rPr sz="1200" b="0">
+                <a:solidFill>
+                  <a:srgbClr val="1A1A1A"/>
+                </a:solidFill>
+              </a:rPr>
+              <a:t>▪  Footer line: 'Filing automatically in Xs' replaces the redundant descriptive text</a:t>
+            </a:r>
+          </a:p>
+        </p:txBody>
+      </p:sp>
+      <p:sp>
+        <p:nvSpPr>
+          <p:cNvPr id="20" name="TextBox 19"/>
+          <p:cNvSpPr txBox="1"/>
+          <p:nvPr/>
+        </p:nvSpPr>
+        <p:spPr>
+          <a:xfrm>
+            <a:off x="457200" y="4832604"/>
+            <a:ext cx="11091672" cy="365760"/>
+          </a:xfrm>
+          <a:prstGeom prst="rect">
+            <a:avLst/>
+          </a:prstGeom>
+          <a:noFill/>
+        </p:spPr>
+        <p:txBody>
+          <a:bodyPr wrap="square" lIns="0" rIns="0" tIns="0" bIns="0">
+            <a:spAutoFit/>
+          </a:bodyPr>
+          <a:lstStyle/>
+          <a:p>
+            <a:pPr algn="l"/>
+            <a:r>
+              <a:rPr sz="1400" b="1">
+                <a:solidFill>
+                  <a:srgbClr val="C8102E"/>
+                </a:solidFill>
+              </a:rPr>
+              <a:t>Why it matters</a:t>
+            </a:r>
+          </a:p>
+        </p:txBody>
+      </p:sp>
+      <p:sp>
+        <p:nvSpPr>
+          <p:cNvPr id="21" name="TextBox 20"/>
+          <p:cNvSpPr txBox="1"/>
+          <p:nvPr/>
+        </p:nvSpPr>
+        <p:spPr>
+          <a:xfrm>
+            <a:off x="640080" y="5198364"/>
+            <a:ext cx="10908792" cy="285750"/>
+          </a:xfrm>
+          <a:prstGeom prst="rect">
+            <a:avLst/>
+          </a:prstGeom>
+          <a:noFill/>
+        </p:spPr>
+        <p:txBody>
+          <a:bodyPr wrap="square" lIns="0" rIns="0" tIns="0" bIns="0">
+            <a:spAutoFit/>
+          </a:bodyPr>
+          <a:lstStyle/>
+          <a:p>
+            <a:pPr algn="l"/>
+            <a:r>
+              <a:rPr sz="1200" b="0">
+                <a:solidFill>
+                  <a:srgbClr val="1A1A1A"/>
+                </a:solidFill>
+              </a:rPr>
+              <a:t>▪  Alarm framing on a confirmation screen increases task abandonment. Calm copy + a neutral cancel</a:t>
+            </a:r>
+          </a:p>
+        </p:txBody>
+      </p:sp>
+      <p:sp>
+        <p:nvSpPr>
+          <p:cNvPr id="22" name="TextBox 21"/>
+          <p:cNvSpPr txBox="1"/>
+          <p:nvPr/>
+        </p:nvSpPr>
+        <p:spPr>
+          <a:xfrm>
+            <a:off x="640080" y="5484114"/>
+            <a:ext cx="10908792" cy="285750"/>
+          </a:xfrm>
+          <a:prstGeom prst="rect">
+            <a:avLst/>
+          </a:prstGeom>
+          <a:noFill/>
+        </p:spPr>
+        <p:txBody>
+          <a:bodyPr wrap="square" lIns="0" rIns="0" tIns="0" bIns="0">
+            <a:spAutoFit/>
+          </a:bodyPr>
+          <a:lstStyle/>
+          <a:p>
+            <a:pPr algn="l"/>
+            <a:r>
+              <a:rPr sz="1200" b="0">
+                <a:solidFill>
+                  <a:srgbClr val="1A1A1A"/>
+                </a:solidFill>
+              </a:rPr>
+              <a:t>▪  button reduce anxiety without hiding the escape hatch — a standard reassurance pattern.</a:t>
+            </a:r>
+          </a:p>
+        </p:txBody>
+      </p:sp>
+      <p:sp>
+        <p:nvSpPr>
+          <p:cNvPr id="23" name="Rectangle 22"/>
+          <p:cNvSpPr/>
+          <p:nvPr/>
+        </p:nvSpPr>
+        <p:spPr>
+          <a:xfrm>
+            <a:off x="457200" y="6217920"/>
+            <a:ext cx="11274552" cy="457200"/>
+          </a:xfrm>
+          <a:prstGeom prst="rect">
+            <a:avLst/>
+          </a:prstGeom>
+          <a:solidFill>
+            <a:srgbClr val="F5F0E8"/>
+          </a:solidFill>
+          <a:ln>
+            <a:noFill/>
+          </a:ln>
+        </p:spPr>
+        <p:style>
+          <a:lnRef idx="1">
+            <a:schemeClr val="accent1"/>
+          </a:lnRef>
+          <a:fillRef idx="3">
+            <a:schemeClr val="accent1"/>
+          </a:fillRef>
+          <a:effectRef idx="2">
+            <a:schemeClr val="accent1"/>
+          </a:effectRef>
+          <a:fontRef idx="minor">
+            <a:schemeClr val="lt1"/>
+          </a:fontRef>
+        </p:style>
+        <p:txBody>
+          <a:bodyPr rtlCol="0" anchor="ctr"/>
+          <a:lstStyle/>
+          <a:p>
+            <a:pPr algn="ctr"/>
+          </a:p>
+        </p:txBody>
+      </p:sp>
+      <p:sp>
+        <p:nvSpPr>
+          <p:cNvPr id="24" name="TextBox 23"/>
+          <p:cNvSpPr txBox="1"/>
+          <p:nvPr/>
+        </p:nvSpPr>
+        <p:spPr>
+          <a:xfrm>
+            <a:off x="640080" y="6263640"/>
+            <a:ext cx="11091672" cy="365760"/>
+          </a:xfrm>
+          <a:prstGeom prst="rect">
+            <a:avLst/>
+          </a:prstGeom>
+          <a:noFill/>
+        </p:spPr>
+        <p:txBody>
+          <a:bodyPr wrap="square" lIns="0" rIns="0" tIns="0" bIns="0">
+            <a:spAutoFit/>
+          </a:bodyPr>
+          <a:lstStyle/>
+          <a:p>
+            <a:pPr algn="l"/>
+            <a:r>
+              <a:rPr sz="1000" b="0">
+                <a:solidFill>
+                  <a:srgbClr val="78716C"/>
+                </a:solidFill>
+              </a:rPr>
+              <a:t>Session 2 · 23 Jun 2026  ·  VAT countdown overlay ~line 4998 (renderMtdSubmit)</a:t>
             </a:r>
           </a:p>
         </p:txBody>

</xml_diff>